<commit_message>
feat: versão final - todos os arquivos atualizados
</commit_message>
<xml_diff>
--- a/dengue-recife/relatorio_dengue_recife.pptx
+++ b/dengue-recife/relatorio_dengue_recife.pptx
@@ -5,11 +5,19 @@
     <p:sldMasterId id="2147483648" r:id="rId1"/>
   </p:sldMasterIdLst>
   <p:sldIdLst>
-    <p:sldId id="256" r:id="rId7"/>
-    <p:sldId id="257" r:id="rId8"/>
-    <p:sldId id="258" r:id="rId9"/>
-    <p:sldId id="259" r:id="rId10"/>
-    <p:sldId id="260" r:id="rId11"/>
+    <p:sldId id="256" r:id="rId2"/>
+    <p:sldId id="257" r:id="rId3"/>
+    <p:sldId id="258" r:id="rId4"/>
+    <p:sldId id="259" r:id="rId5"/>
+    <p:sldId id="260" r:id="rId6"/>
+    <p:sldId id="261" r:id="rId7"/>
+    <p:sldId id="262" r:id="rId8"/>
+    <p:sldId id="263" r:id="rId9"/>
+    <p:sldId id="264" r:id="rId10"/>
+    <p:sldId id="265" r:id="rId11"/>
+    <p:sldId id="266" r:id="rId12"/>
+    <p:sldId id="267" r:id="rId13"/>
+    <p:sldId id="268" r:id="rId14"/>
   </p:sldIdLst>
   <p:sldSz cx="9144000" cy="6858000" type="screen4x3"/>
   <p:notesSz cx="6858000" cy="9144000"/>
@@ -108,6 +116,22 @@
       </a:defRPr>
     </a:lvl9pPr>
   </p:defaultTextStyle>
+  <p:extLst>
+    <p:ext uri="{EFAFB233-063F-42B5-8137-9DF3F51BA10A}">
+      <p15:sldGuideLst xmlns:p15="http://schemas.microsoft.com/office/powerpoint/2012/main">
+        <p15:guide id="1" orient="horz" pos="2160">
+          <p15:clr>
+            <a:srgbClr val="A4A3A4"/>
+          </p15:clr>
+        </p15:guide>
+        <p15:guide id="2" pos="2880">
+          <p15:clr>
+            <a:srgbClr val="A4A3A4"/>
+          </p15:clr>
+        </p15:guide>
+      </p15:sldGuideLst>
+    </p:ext>
+  </p:extLst>
 </p:presentation>
 </file>
 
@@ -149,10 +173,9 @@
           <a:lstStyle/>
           <a:p>
             <a:r>
-              <a:rPr lang="en-US" smtClean="0"/>
+              <a:rPr lang="en-US"/>
               <a:t>Click to edit Master title style</a:t>
             </a:r>
-            <a:endParaRPr lang="en-US"/>
           </a:p>
         </p:txBody>
       </p:sp>
@@ -268,10 +291,9 @@
           </a:lstStyle>
           <a:p>
             <a:r>
-              <a:rPr lang="en-US" smtClean="0"/>
+              <a:rPr lang="en-US"/>
               <a:t>Click to edit Master subtitle style</a:t>
             </a:r>
-            <a:endParaRPr lang="en-US"/>
           </a:p>
         </p:txBody>
       </p:sp>
@@ -292,7 +314,7 @@
           <a:p>
             <a:fld id="{5BCAD085-E8A6-8845-BD4E-CB4CCA059FC4}" type="datetimeFigureOut">
               <a:rPr lang="en-US" smtClean="0"/>
-              <a:t>1/27/13</a:t>
+              <a:t>5/8/2026</a:t>
             </a:fld>
             <a:endParaRPr lang="en-US"/>
           </a:p>
@@ -334,7 +356,7 @@
           <a:p>
             <a:fld id="{C1FF6DA9-008F-8B48-92A6-B652298478BF}" type="slidenum">
               <a:rPr lang="en-US" smtClean="0"/>
-              <a:t>‹#›</a:t>
+              <a:t>‹nº›</a:t>
             </a:fld>
             <a:endParaRPr lang="en-US"/>
           </a:p>
@@ -386,10 +408,9 @@
           <a:lstStyle/>
           <a:p>
             <a:r>
-              <a:rPr lang="en-US" smtClean="0"/>
+              <a:rPr lang="en-US"/>
               <a:t>Click to edit Master title style</a:t>
             </a:r>
-            <a:endParaRPr lang="en-US"/>
           </a:p>
         </p:txBody>
       </p:sp>
@@ -410,38 +431,37 @@
           <a:p>
             <a:pPr lvl="0"/>
             <a:r>
-              <a:rPr lang="en-US" smtClean="0"/>
+              <a:rPr lang="en-US"/>
               <a:t>Click to edit Master text styles</a:t>
             </a:r>
           </a:p>
           <a:p>
             <a:pPr lvl="1"/>
             <a:r>
-              <a:rPr lang="en-US" smtClean="0"/>
+              <a:rPr lang="en-US"/>
               <a:t>Second level</a:t>
             </a:r>
           </a:p>
           <a:p>
             <a:pPr lvl="2"/>
             <a:r>
-              <a:rPr lang="en-US" smtClean="0"/>
+              <a:rPr lang="en-US"/>
               <a:t>Third level</a:t>
             </a:r>
           </a:p>
           <a:p>
             <a:pPr lvl="3"/>
             <a:r>
-              <a:rPr lang="en-US" smtClean="0"/>
+              <a:rPr lang="en-US"/>
               <a:t>Fourth level</a:t>
             </a:r>
           </a:p>
           <a:p>
             <a:pPr lvl="4"/>
             <a:r>
-              <a:rPr lang="en-US" smtClean="0"/>
+              <a:rPr lang="en-US"/>
               <a:t>Fifth level</a:t>
             </a:r>
-            <a:endParaRPr lang="en-US"/>
           </a:p>
         </p:txBody>
       </p:sp>
@@ -462,7 +482,7 @@
           <a:p>
             <a:fld id="{5BCAD085-E8A6-8845-BD4E-CB4CCA059FC4}" type="datetimeFigureOut">
               <a:rPr lang="en-US" smtClean="0"/>
-              <a:t>1/27/13</a:t>
+              <a:t>5/8/2026</a:t>
             </a:fld>
             <a:endParaRPr lang="en-US"/>
           </a:p>
@@ -504,7 +524,7 @@
           <a:p>
             <a:fld id="{C1FF6DA9-008F-8B48-92A6-B652298478BF}" type="slidenum">
               <a:rPr lang="en-US" smtClean="0"/>
-              <a:t>‹#›</a:t>
+              <a:t>‹nº›</a:t>
             </a:fld>
             <a:endParaRPr lang="en-US"/>
           </a:p>
@@ -561,10 +581,9 @@
           <a:lstStyle/>
           <a:p>
             <a:r>
-              <a:rPr lang="en-US" smtClean="0"/>
+              <a:rPr lang="en-US"/>
               <a:t>Click to edit Master title style</a:t>
             </a:r>
-            <a:endParaRPr lang="en-US"/>
           </a:p>
         </p:txBody>
       </p:sp>
@@ -590,38 +609,37 @@
           <a:p>
             <a:pPr lvl="0"/>
             <a:r>
-              <a:rPr lang="en-US" smtClean="0"/>
+              <a:rPr lang="en-US"/>
               <a:t>Click to edit Master text styles</a:t>
             </a:r>
           </a:p>
           <a:p>
             <a:pPr lvl="1"/>
             <a:r>
-              <a:rPr lang="en-US" smtClean="0"/>
+              <a:rPr lang="en-US"/>
               <a:t>Second level</a:t>
             </a:r>
           </a:p>
           <a:p>
             <a:pPr lvl="2"/>
             <a:r>
-              <a:rPr lang="en-US" smtClean="0"/>
+              <a:rPr lang="en-US"/>
               <a:t>Third level</a:t>
             </a:r>
           </a:p>
           <a:p>
             <a:pPr lvl="3"/>
             <a:r>
-              <a:rPr lang="en-US" smtClean="0"/>
+              <a:rPr lang="en-US"/>
               <a:t>Fourth level</a:t>
             </a:r>
           </a:p>
           <a:p>
             <a:pPr lvl="4"/>
             <a:r>
-              <a:rPr lang="en-US" smtClean="0"/>
+              <a:rPr lang="en-US"/>
               <a:t>Fifth level</a:t>
             </a:r>
-            <a:endParaRPr lang="en-US"/>
           </a:p>
         </p:txBody>
       </p:sp>
@@ -642,7 +660,7 @@
           <a:p>
             <a:fld id="{5BCAD085-E8A6-8845-BD4E-CB4CCA059FC4}" type="datetimeFigureOut">
               <a:rPr lang="en-US" smtClean="0"/>
-              <a:t>1/27/13</a:t>
+              <a:t>5/8/2026</a:t>
             </a:fld>
             <a:endParaRPr lang="en-US"/>
           </a:p>
@@ -684,7 +702,7 @@
           <a:p>
             <a:fld id="{C1FF6DA9-008F-8B48-92A6-B652298478BF}" type="slidenum">
               <a:rPr lang="en-US" smtClean="0"/>
-              <a:t>‹#›</a:t>
+              <a:t>‹nº›</a:t>
             </a:fld>
             <a:endParaRPr lang="en-US"/>
           </a:p>
@@ -736,10 +754,9 @@
           <a:lstStyle/>
           <a:p>
             <a:r>
-              <a:rPr lang="en-US" smtClean="0"/>
+              <a:rPr lang="en-US"/>
               <a:t>Click to edit Master title style</a:t>
             </a:r>
-            <a:endParaRPr lang="en-US"/>
           </a:p>
         </p:txBody>
       </p:sp>
@@ -760,38 +777,37 @@
           <a:p>
             <a:pPr lvl="0"/>
             <a:r>
-              <a:rPr lang="en-US" smtClean="0"/>
+              <a:rPr lang="en-US"/>
               <a:t>Click to edit Master text styles</a:t>
             </a:r>
           </a:p>
           <a:p>
             <a:pPr lvl="1"/>
             <a:r>
-              <a:rPr lang="en-US" smtClean="0"/>
+              <a:rPr lang="en-US"/>
               <a:t>Second level</a:t>
             </a:r>
           </a:p>
           <a:p>
             <a:pPr lvl="2"/>
             <a:r>
-              <a:rPr lang="en-US" smtClean="0"/>
+              <a:rPr lang="en-US"/>
               <a:t>Third level</a:t>
             </a:r>
           </a:p>
           <a:p>
             <a:pPr lvl="3"/>
             <a:r>
-              <a:rPr lang="en-US" smtClean="0"/>
+              <a:rPr lang="en-US"/>
               <a:t>Fourth level</a:t>
             </a:r>
           </a:p>
           <a:p>
             <a:pPr lvl="4"/>
             <a:r>
-              <a:rPr lang="en-US" smtClean="0"/>
+              <a:rPr lang="en-US"/>
               <a:t>Fifth level</a:t>
             </a:r>
-            <a:endParaRPr lang="en-US"/>
           </a:p>
         </p:txBody>
       </p:sp>
@@ -812,7 +828,7 @@
           <a:p>
             <a:fld id="{5BCAD085-E8A6-8845-BD4E-CB4CCA059FC4}" type="datetimeFigureOut">
               <a:rPr lang="en-US" smtClean="0"/>
-              <a:t>1/27/13</a:t>
+              <a:t>5/8/2026</a:t>
             </a:fld>
             <a:endParaRPr lang="en-US"/>
           </a:p>
@@ -854,7 +870,7 @@
           <a:p>
             <a:fld id="{C1FF6DA9-008F-8B48-92A6-B652298478BF}" type="slidenum">
               <a:rPr lang="en-US" smtClean="0"/>
-              <a:t>‹#›</a:t>
+              <a:t>‹nº›</a:t>
             </a:fld>
             <a:endParaRPr lang="en-US"/>
           </a:p>
@@ -915,10 +931,9 @@
           </a:lstStyle>
           <a:p>
             <a:r>
-              <a:rPr lang="en-US" smtClean="0"/>
+              <a:rPr lang="en-US"/>
               <a:t>Click to edit Master title style</a:t>
             </a:r>
-            <a:endParaRPr lang="en-US"/>
           </a:p>
         </p:txBody>
       </p:sp>
@@ -1035,7 +1050,7 @@
           <a:p>
             <a:pPr lvl="0"/>
             <a:r>
-              <a:rPr lang="en-US" smtClean="0"/>
+              <a:rPr lang="en-US"/>
               <a:t>Click to edit Master text styles</a:t>
             </a:r>
           </a:p>
@@ -1058,7 +1073,7 @@
           <a:p>
             <a:fld id="{5BCAD085-E8A6-8845-BD4E-CB4CCA059FC4}" type="datetimeFigureOut">
               <a:rPr lang="en-US" smtClean="0"/>
-              <a:t>1/27/13</a:t>
+              <a:t>5/8/2026</a:t>
             </a:fld>
             <a:endParaRPr lang="en-US"/>
           </a:p>
@@ -1100,7 +1115,7 @@
           <a:p>
             <a:fld id="{C1FF6DA9-008F-8B48-92A6-B652298478BF}" type="slidenum">
               <a:rPr lang="en-US" smtClean="0"/>
-              <a:t>‹#›</a:t>
+              <a:t>‹nº›</a:t>
             </a:fld>
             <a:endParaRPr lang="en-US"/>
           </a:p>
@@ -1152,10 +1167,9 @@
           <a:lstStyle/>
           <a:p>
             <a:r>
-              <a:rPr lang="en-US" smtClean="0"/>
+              <a:rPr lang="en-US"/>
               <a:t>Click to edit Master title style</a:t>
             </a:r>
-            <a:endParaRPr lang="en-US"/>
           </a:p>
         </p:txBody>
       </p:sp>
@@ -1209,38 +1223,37 @@
           <a:p>
             <a:pPr lvl="0"/>
             <a:r>
-              <a:rPr lang="en-US" smtClean="0"/>
+              <a:rPr lang="en-US"/>
               <a:t>Click to edit Master text styles</a:t>
             </a:r>
           </a:p>
           <a:p>
             <a:pPr lvl="1"/>
             <a:r>
-              <a:rPr lang="en-US" smtClean="0"/>
+              <a:rPr lang="en-US"/>
               <a:t>Second level</a:t>
             </a:r>
           </a:p>
           <a:p>
             <a:pPr lvl="2"/>
             <a:r>
-              <a:rPr lang="en-US" smtClean="0"/>
+              <a:rPr lang="en-US"/>
               <a:t>Third level</a:t>
             </a:r>
           </a:p>
           <a:p>
             <a:pPr lvl="3"/>
             <a:r>
-              <a:rPr lang="en-US" smtClean="0"/>
+              <a:rPr lang="en-US"/>
               <a:t>Fourth level</a:t>
             </a:r>
           </a:p>
           <a:p>
             <a:pPr lvl="4"/>
             <a:r>
-              <a:rPr lang="en-US" smtClean="0"/>
+              <a:rPr lang="en-US"/>
               <a:t>Fifth level</a:t>
             </a:r>
-            <a:endParaRPr lang="en-US"/>
           </a:p>
         </p:txBody>
       </p:sp>
@@ -1294,38 +1307,37 @@
           <a:p>
             <a:pPr lvl="0"/>
             <a:r>
-              <a:rPr lang="en-US" smtClean="0"/>
+              <a:rPr lang="en-US"/>
               <a:t>Click to edit Master text styles</a:t>
             </a:r>
           </a:p>
           <a:p>
             <a:pPr lvl="1"/>
             <a:r>
-              <a:rPr lang="en-US" smtClean="0"/>
+              <a:rPr lang="en-US"/>
               <a:t>Second level</a:t>
             </a:r>
           </a:p>
           <a:p>
             <a:pPr lvl="2"/>
             <a:r>
-              <a:rPr lang="en-US" smtClean="0"/>
+              <a:rPr lang="en-US"/>
               <a:t>Third level</a:t>
             </a:r>
           </a:p>
           <a:p>
             <a:pPr lvl="3"/>
             <a:r>
-              <a:rPr lang="en-US" smtClean="0"/>
+              <a:rPr lang="en-US"/>
               <a:t>Fourth level</a:t>
             </a:r>
           </a:p>
           <a:p>
             <a:pPr lvl="4"/>
             <a:r>
-              <a:rPr lang="en-US" smtClean="0"/>
+              <a:rPr lang="en-US"/>
               <a:t>Fifth level</a:t>
             </a:r>
-            <a:endParaRPr lang="en-US"/>
           </a:p>
         </p:txBody>
       </p:sp>
@@ -1346,7 +1358,7 @@
           <a:p>
             <a:fld id="{5BCAD085-E8A6-8845-BD4E-CB4CCA059FC4}" type="datetimeFigureOut">
               <a:rPr lang="en-US" smtClean="0"/>
-              <a:t>1/27/13</a:t>
+              <a:t>5/8/2026</a:t>
             </a:fld>
             <a:endParaRPr lang="en-US"/>
           </a:p>
@@ -1388,7 +1400,7 @@
           <a:p>
             <a:fld id="{C1FF6DA9-008F-8B48-92A6-B652298478BF}" type="slidenum">
               <a:rPr lang="en-US" smtClean="0"/>
-              <a:t>‹#›</a:t>
+              <a:t>‹nº›</a:t>
             </a:fld>
             <a:endParaRPr lang="en-US"/>
           </a:p>
@@ -1444,10 +1456,9 @@
           </a:lstStyle>
           <a:p>
             <a:r>
-              <a:rPr lang="en-US" smtClean="0"/>
+              <a:rPr lang="en-US"/>
               <a:t>Click to edit Master title style</a:t>
             </a:r>
-            <a:endParaRPr lang="en-US"/>
           </a:p>
         </p:txBody>
       </p:sp>
@@ -1510,7 +1521,7 @@
           <a:p>
             <a:pPr lvl="0"/>
             <a:r>
-              <a:rPr lang="en-US" smtClean="0"/>
+              <a:rPr lang="en-US"/>
               <a:t>Click to edit Master text styles</a:t>
             </a:r>
           </a:p>
@@ -1566,38 +1577,37 @@
           <a:p>
             <a:pPr lvl="0"/>
             <a:r>
-              <a:rPr lang="en-US" smtClean="0"/>
+              <a:rPr lang="en-US"/>
               <a:t>Click to edit Master text styles</a:t>
             </a:r>
           </a:p>
           <a:p>
             <a:pPr lvl="1"/>
             <a:r>
-              <a:rPr lang="en-US" smtClean="0"/>
+              <a:rPr lang="en-US"/>
               <a:t>Second level</a:t>
             </a:r>
           </a:p>
           <a:p>
             <a:pPr lvl="2"/>
             <a:r>
-              <a:rPr lang="en-US" smtClean="0"/>
+              <a:rPr lang="en-US"/>
               <a:t>Third level</a:t>
             </a:r>
           </a:p>
           <a:p>
             <a:pPr lvl="3"/>
             <a:r>
-              <a:rPr lang="en-US" smtClean="0"/>
+              <a:rPr lang="en-US"/>
               <a:t>Fourth level</a:t>
             </a:r>
           </a:p>
           <a:p>
             <a:pPr lvl="4"/>
             <a:r>
-              <a:rPr lang="en-US" smtClean="0"/>
+              <a:rPr lang="en-US"/>
               <a:t>Fifth level</a:t>
             </a:r>
-            <a:endParaRPr lang="en-US"/>
           </a:p>
         </p:txBody>
       </p:sp>
@@ -1660,7 +1670,7 @@
           <a:p>
             <a:pPr lvl="0"/>
             <a:r>
-              <a:rPr lang="en-US" smtClean="0"/>
+              <a:rPr lang="en-US"/>
               <a:t>Click to edit Master text styles</a:t>
             </a:r>
           </a:p>
@@ -1716,38 +1726,37 @@
           <a:p>
             <a:pPr lvl="0"/>
             <a:r>
-              <a:rPr lang="en-US" smtClean="0"/>
+              <a:rPr lang="en-US"/>
               <a:t>Click to edit Master text styles</a:t>
             </a:r>
           </a:p>
           <a:p>
             <a:pPr lvl="1"/>
             <a:r>
-              <a:rPr lang="en-US" smtClean="0"/>
+              <a:rPr lang="en-US"/>
               <a:t>Second level</a:t>
             </a:r>
           </a:p>
           <a:p>
             <a:pPr lvl="2"/>
             <a:r>
-              <a:rPr lang="en-US" smtClean="0"/>
+              <a:rPr lang="en-US"/>
               <a:t>Third level</a:t>
             </a:r>
           </a:p>
           <a:p>
             <a:pPr lvl="3"/>
             <a:r>
-              <a:rPr lang="en-US" smtClean="0"/>
+              <a:rPr lang="en-US"/>
               <a:t>Fourth level</a:t>
             </a:r>
           </a:p>
           <a:p>
             <a:pPr lvl="4"/>
             <a:r>
-              <a:rPr lang="en-US" smtClean="0"/>
+              <a:rPr lang="en-US"/>
               <a:t>Fifth level</a:t>
             </a:r>
-            <a:endParaRPr lang="en-US"/>
           </a:p>
         </p:txBody>
       </p:sp>
@@ -1768,7 +1777,7 @@
           <a:p>
             <a:fld id="{5BCAD085-E8A6-8845-BD4E-CB4CCA059FC4}" type="datetimeFigureOut">
               <a:rPr lang="en-US" smtClean="0"/>
-              <a:t>1/27/13</a:t>
+              <a:t>5/8/2026</a:t>
             </a:fld>
             <a:endParaRPr lang="en-US"/>
           </a:p>
@@ -1810,7 +1819,7 @@
           <a:p>
             <a:fld id="{C1FF6DA9-008F-8B48-92A6-B652298478BF}" type="slidenum">
               <a:rPr lang="en-US" smtClean="0"/>
-              <a:t>‹#›</a:t>
+              <a:t>‹nº›</a:t>
             </a:fld>
             <a:endParaRPr lang="en-US"/>
           </a:p>
@@ -1862,10 +1871,9 @@
           <a:lstStyle/>
           <a:p>
             <a:r>
-              <a:rPr lang="en-US" smtClean="0"/>
+              <a:rPr lang="en-US"/>
               <a:t>Click to edit Master title style</a:t>
             </a:r>
-            <a:endParaRPr lang="en-US"/>
           </a:p>
         </p:txBody>
       </p:sp>
@@ -1886,7 +1894,7 @@
           <a:p>
             <a:fld id="{5BCAD085-E8A6-8845-BD4E-CB4CCA059FC4}" type="datetimeFigureOut">
               <a:rPr lang="en-US" smtClean="0"/>
-              <a:t>1/27/13</a:t>
+              <a:t>5/8/2026</a:t>
             </a:fld>
             <a:endParaRPr lang="en-US"/>
           </a:p>
@@ -1928,7 +1936,7 @@
           <a:p>
             <a:fld id="{C1FF6DA9-008F-8B48-92A6-B652298478BF}" type="slidenum">
               <a:rPr lang="en-US" smtClean="0"/>
-              <a:t>‹#›</a:t>
+              <a:t>‹nº›</a:t>
             </a:fld>
             <a:endParaRPr lang="en-US"/>
           </a:p>
@@ -1981,7 +1989,7 @@
           <a:p>
             <a:fld id="{5BCAD085-E8A6-8845-BD4E-CB4CCA059FC4}" type="datetimeFigureOut">
               <a:rPr lang="en-US" smtClean="0"/>
-              <a:t>1/27/13</a:t>
+              <a:t>5/8/2026</a:t>
             </a:fld>
             <a:endParaRPr lang="en-US"/>
           </a:p>
@@ -2023,7 +2031,7 @@
           <a:p>
             <a:fld id="{C1FF6DA9-008F-8B48-92A6-B652298478BF}" type="slidenum">
               <a:rPr lang="en-US" smtClean="0"/>
-              <a:t>‹#›</a:t>
+              <a:t>‹nº›</a:t>
             </a:fld>
             <a:endParaRPr lang="en-US"/>
           </a:p>
@@ -2084,10 +2092,9 @@
           </a:lstStyle>
           <a:p>
             <a:r>
-              <a:rPr lang="en-US" smtClean="0"/>
+              <a:rPr lang="en-US"/>
               <a:t>Click to edit Master title style</a:t>
             </a:r>
-            <a:endParaRPr lang="en-US"/>
           </a:p>
         </p:txBody>
       </p:sp>
@@ -2141,38 +2148,37 @@
           <a:p>
             <a:pPr lvl="0"/>
             <a:r>
-              <a:rPr lang="en-US" smtClean="0"/>
+              <a:rPr lang="en-US"/>
               <a:t>Click to edit Master text styles</a:t>
             </a:r>
           </a:p>
           <a:p>
             <a:pPr lvl="1"/>
             <a:r>
-              <a:rPr lang="en-US" smtClean="0"/>
+              <a:rPr lang="en-US"/>
               <a:t>Second level</a:t>
             </a:r>
           </a:p>
           <a:p>
             <a:pPr lvl="2"/>
             <a:r>
-              <a:rPr lang="en-US" smtClean="0"/>
+              <a:rPr lang="en-US"/>
               <a:t>Third level</a:t>
             </a:r>
           </a:p>
           <a:p>
             <a:pPr lvl="3"/>
             <a:r>
-              <a:rPr lang="en-US" smtClean="0"/>
+              <a:rPr lang="en-US"/>
               <a:t>Fourth level</a:t>
             </a:r>
           </a:p>
           <a:p>
             <a:pPr lvl="4"/>
             <a:r>
-              <a:rPr lang="en-US" smtClean="0"/>
+              <a:rPr lang="en-US"/>
               <a:t>Fifth level</a:t>
             </a:r>
-            <a:endParaRPr lang="en-US"/>
           </a:p>
         </p:txBody>
       </p:sp>
@@ -2235,7 +2241,7 @@
           <a:p>
             <a:pPr lvl="0"/>
             <a:r>
-              <a:rPr lang="en-US" smtClean="0"/>
+              <a:rPr lang="en-US"/>
               <a:t>Click to edit Master text styles</a:t>
             </a:r>
           </a:p>
@@ -2258,7 +2264,7 @@
           <a:p>
             <a:fld id="{5BCAD085-E8A6-8845-BD4E-CB4CCA059FC4}" type="datetimeFigureOut">
               <a:rPr lang="en-US" smtClean="0"/>
-              <a:t>1/27/13</a:t>
+              <a:t>5/8/2026</a:t>
             </a:fld>
             <a:endParaRPr lang="en-US"/>
           </a:p>
@@ -2300,7 +2306,7 @@
           <a:p>
             <a:fld id="{C1FF6DA9-008F-8B48-92A6-B652298478BF}" type="slidenum">
               <a:rPr lang="en-US" smtClean="0"/>
-              <a:t>‹#›</a:t>
+              <a:t>‹nº›</a:t>
             </a:fld>
             <a:endParaRPr lang="en-US"/>
           </a:p>
@@ -2361,10 +2367,9 @@
           </a:lstStyle>
           <a:p>
             <a:r>
-              <a:rPr lang="en-US" smtClean="0"/>
+              <a:rPr lang="en-US"/>
               <a:t>Click to edit Master title style</a:t>
             </a:r>
-            <a:endParaRPr lang="en-US"/>
           </a:p>
         </p:txBody>
       </p:sp>
@@ -2488,7 +2493,7 @@
           <a:p>
             <a:pPr lvl="0"/>
             <a:r>
-              <a:rPr lang="en-US" smtClean="0"/>
+              <a:rPr lang="en-US"/>
               <a:t>Click to edit Master text styles</a:t>
             </a:r>
           </a:p>
@@ -2511,7 +2516,7 @@
           <a:p>
             <a:fld id="{5BCAD085-E8A6-8845-BD4E-CB4CCA059FC4}" type="datetimeFigureOut">
               <a:rPr lang="en-US" smtClean="0"/>
-              <a:t>1/27/13</a:t>
+              <a:t>5/8/2026</a:t>
             </a:fld>
             <a:endParaRPr lang="en-US"/>
           </a:p>
@@ -2553,7 +2558,7 @@
           <a:p>
             <a:fld id="{C1FF6DA9-008F-8B48-92A6-B652298478BF}" type="slidenum">
               <a:rPr lang="en-US" smtClean="0"/>
-              <a:t>‹#›</a:t>
+              <a:t>‹nº›</a:t>
             </a:fld>
             <a:endParaRPr lang="en-US"/>
           </a:p>
@@ -2620,10 +2625,9 @@
           <a:lstStyle/>
           <a:p>
             <a:r>
-              <a:rPr lang="en-US" smtClean="0"/>
+              <a:rPr lang="en-US"/>
               <a:t>Click to edit Master title style</a:t>
             </a:r>
-            <a:endParaRPr lang="en-US"/>
           </a:p>
         </p:txBody>
       </p:sp>
@@ -2654,38 +2658,37 @@
           <a:p>
             <a:pPr lvl="0"/>
             <a:r>
-              <a:rPr lang="en-US" smtClean="0"/>
+              <a:rPr lang="en-US"/>
               <a:t>Click to edit Master text styles</a:t>
             </a:r>
           </a:p>
           <a:p>
             <a:pPr lvl="1"/>
             <a:r>
-              <a:rPr lang="en-US" smtClean="0"/>
+              <a:rPr lang="en-US"/>
               <a:t>Second level</a:t>
             </a:r>
           </a:p>
           <a:p>
             <a:pPr lvl="2"/>
             <a:r>
-              <a:rPr lang="en-US" smtClean="0"/>
+              <a:rPr lang="en-US"/>
               <a:t>Third level</a:t>
             </a:r>
           </a:p>
           <a:p>
             <a:pPr lvl="3"/>
             <a:r>
-              <a:rPr lang="en-US" smtClean="0"/>
+              <a:rPr lang="en-US"/>
               <a:t>Fourth level</a:t>
             </a:r>
           </a:p>
           <a:p>
             <a:pPr lvl="4"/>
             <a:r>
-              <a:rPr lang="en-US" smtClean="0"/>
+              <a:rPr lang="en-US"/>
               <a:t>Fifth level</a:t>
             </a:r>
-            <a:endParaRPr lang="en-US"/>
           </a:p>
         </p:txBody>
       </p:sp>
@@ -2724,7 +2727,7 @@
           <a:p>
             <a:fld id="{5BCAD085-E8A6-8845-BD4E-CB4CCA059FC4}" type="datetimeFigureOut">
               <a:rPr lang="en-US" smtClean="0"/>
-              <a:t>1/27/13</a:t>
+              <a:t>5/8/2026</a:t>
             </a:fld>
             <a:endParaRPr lang="en-US"/>
           </a:p>
@@ -2802,7 +2805,7 @@
           <a:p>
             <a:fld id="{C1FF6DA9-008F-8B48-92A6-B652298478BF}" type="slidenum">
               <a:rPr lang="en-US" smtClean="0"/>
-              <a:t>‹#›</a:t>
+              <a:t>‹nº›</a:t>
             </a:fld>
             <a:endParaRPr lang="en-US"/>
           </a:p>
@@ -3083,33 +3086,288 @@
 </file>
 
 <file path=ppt/slides/slide1.xml><?xml version="1.0" encoding="utf-8"?>
-<p:sld xmlns:a="http://schemas.openxmlformats.org/drawingml/2006/main" xmlns:p="http://schemas.openxmlformats.org/presentationml/2006/main" xmlns:r="http://schemas.openxmlformats.org/officeDocument/2006/relationships">
+<p:sld xmlns:a="http://schemas.openxmlformats.org/drawingml/2006/main" xmlns:r="http://schemas.openxmlformats.org/officeDocument/2006/relationships" xmlns:p="http://schemas.openxmlformats.org/presentationml/2006/main">
   <p:cSld>
+    <p:bg>
+      <p:bgPr>
+        <a:solidFill>
+          <a:srgbClr val="1A1410"/>
+        </a:solidFill>
+        <a:effectLst/>
+      </p:bgPr>
+    </p:bg>
     <p:spTree>
       <p:nvGrpSpPr>
         <p:cNvPr id="1" name=""/>
         <p:cNvGrpSpPr/>
         <p:nvPr/>
       </p:nvGrpSpPr>
-      <p:grpSpPr/>
-      <p:sp>
-        <p:nvSpPr>
-          <p:cNvPr id="2" name="Title 1"/>
-          <p:cNvSpPr>
-            <a:spLocks noGrp="1"/>
-          </p:cNvSpPr>
-          <p:nvPr>
-            <p:ph type="title"/>
-          </p:nvPr>
-        </p:nvSpPr>
-        <p:spPr/>
-        <p:txBody>
-          <a:bodyPr/>
-          <a:lstStyle/>
-          <a:p>
-            <a:r>
-              <a:t>Análise de Dengue em Recife</a:t>
-            </a:r>
+      <p:grpSpPr>
+        <a:xfrm>
+          <a:off x="0" y="0"/>
+          <a:ext cx="0" cy="0"/>
+          <a:chOff x="0" y="0"/>
+          <a:chExt cx="0" cy="0"/>
+        </a:xfrm>
+      </p:grpSpPr>
+      <p:sp>
+        <p:nvSpPr>
+          <p:cNvPr id="2" name="Rectangle 1"/>
+          <p:cNvSpPr/>
+          <p:nvPr/>
+        </p:nvSpPr>
+        <p:spPr>
+          <a:xfrm>
+            <a:off x="0" y="0"/>
+            <a:ext cx="109728" cy="6858000"/>
+          </a:xfrm>
+          <a:prstGeom prst="rect">
+            <a:avLst/>
+          </a:prstGeom>
+          <a:solidFill>
+            <a:srgbClr val="C8382A"/>
+          </a:solidFill>
+          <a:ln>
+            <a:noFill/>
+          </a:ln>
+        </p:spPr>
+        <p:style>
+          <a:lnRef idx="1">
+            <a:schemeClr val="accent1"/>
+          </a:lnRef>
+          <a:fillRef idx="3">
+            <a:schemeClr val="accent1"/>
+          </a:fillRef>
+          <a:effectRef idx="2">
+            <a:schemeClr val="accent1"/>
+          </a:effectRef>
+          <a:fontRef idx="minor">
+            <a:schemeClr val="lt1"/>
+          </a:fontRef>
+        </p:style>
+        <p:txBody>
+          <a:bodyPr rtlCol="0" anchor="ctr"/>
+          <a:lstStyle/>
+          <a:p>
+            <a:pPr algn="ctr"/>
+            <a:endParaRPr/>
+          </a:p>
+        </p:txBody>
+      </p:sp>
+      <p:sp>
+        <p:nvSpPr>
+          <p:cNvPr id="3" name="TextBox 2"/>
+          <p:cNvSpPr txBox="1"/>
+          <p:nvPr/>
+        </p:nvSpPr>
+        <p:spPr>
+          <a:xfrm>
+            <a:off x="365760" y="1097280"/>
+            <a:ext cx="8229600" cy="1097280"/>
+          </a:xfrm>
+          <a:prstGeom prst="rect">
+            <a:avLst/>
+          </a:prstGeom>
+          <a:noFill/>
+        </p:spPr>
+        <p:txBody>
+          <a:bodyPr wrap="square">
+            <a:spAutoFit/>
+          </a:bodyPr>
+          <a:lstStyle/>
+          <a:p>
+            <a:pPr algn="l"/>
+            <a:r>
+              <a:rPr sz="4800" b="1">
+                <a:solidFill>
+                  <a:srgbClr val="FFFFFF"/>
+                </a:solidFill>
+              </a:rPr>
+              <a:t>DengueAlert</a:t>
+            </a:r>
+          </a:p>
+        </p:txBody>
+      </p:sp>
+      <p:sp>
+        <p:nvSpPr>
+          <p:cNvPr id="4" name="TextBox 3"/>
+          <p:cNvSpPr txBox="1"/>
+          <p:nvPr/>
+        </p:nvSpPr>
+        <p:spPr>
+          <a:xfrm>
+            <a:off x="365760" y="2011680"/>
+            <a:ext cx="8229600" cy="914400"/>
+          </a:xfrm>
+          <a:prstGeom prst="rect">
+            <a:avLst/>
+          </a:prstGeom>
+          <a:noFill/>
+        </p:spPr>
+        <p:txBody>
+          <a:bodyPr wrap="square">
+            <a:spAutoFit/>
+          </a:bodyPr>
+          <a:lstStyle/>
+          <a:p>
+            <a:pPr algn="l"/>
+            <a:r>
+              <a:rPr sz="4800" b="1">
+                <a:solidFill>
+                  <a:srgbClr val="C8382A"/>
+                </a:solidFill>
+              </a:rPr>
+              <a:t>Recife</a:t>
+            </a:r>
+          </a:p>
+        </p:txBody>
+      </p:sp>
+      <p:sp>
+        <p:nvSpPr>
+          <p:cNvPr id="5" name="TextBox 4"/>
+          <p:cNvSpPr txBox="1"/>
+          <p:nvPr/>
+        </p:nvSpPr>
+        <p:spPr>
+          <a:xfrm>
+            <a:off x="365760" y="3017520"/>
+            <a:ext cx="8229600" cy="731520"/>
+          </a:xfrm>
+          <a:prstGeom prst="rect">
+            <a:avLst/>
+          </a:prstGeom>
+          <a:noFill/>
+        </p:spPr>
+        <p:txBody>
+          <a:bodyPr wrap="square">
+            <a:spAutoFit/>
+          </a:bodyPr>
+          <a:lstStyle/>
+          <a:p>
+            <a:pPr algn="l"/>
+            <a:r>
+              <a:rPr sz="1600" b="0">
+                <a:solidFill>
+                  <a:srgbClr val="CCBBBB"/>
+                </a:solidFill>
+              </a:rPr>
+              <a:t>Previsão de casos de dengue com Machine Learning e dados reais</a:t>
+            </a:r>
+          </a:p>
+        </p:txBody>
+      </p:sp>
+      <p:sp>
+        <p:nvSpPr>
+          <p:cNvPr id="6" name="Rectangle 5"/>
+          <p:cNvSpPr/>
+          <p:nvPr/>
+        </p:nvSpPr>
+        <p:spPr>
+          <a:xfrm>
+            <a:off x="365760" y="3931920"/>
+            <a:ext cx="8412480" cy="27432"/>
+          </a:xfrm>
+          <a:prstGeom prst="rect">
+            <a:avLst/>
+          </a:prstGeom>
+          <a:solidFill>
+            <a:srgbClr val="443835"/>
+          </a:solidFill>
+          <a:ln>
+            <a:noFill/>
+          </a:ln>
+        </p:spPr>
+        <p:style>
+          <a:lnRef idx="1">
+            <a:schemeClr val="accent1"/>
+          </a:lnRef>
+          <a:fillRef idx="3">
+            <a:schemeClr val="accent1"/>
+          </a:fillRef>
+          <a:effectRef idx="2">
+            <a:schemeClr val="accent1"/>
+          </a:effectRef>
+          <a:fontRef idx="minor">
+            <a:schemeClr val="lt1"/>
+          </a:fontRef>
+        </p:style>
+        <p:txBody>
+          <a:bodyPr rtlCol="0" anchor="ctr"/>
+          <a:lstStyle/>
+          <a:p>
+            <a:pPr algn="ctr"/>
+            <a:endParaRPr/>
+          </a:p>
+        </p:txBody>
+      </p:sp>
+      <p:sp>
+        <p:nvSpPr>
+          <p:cNvPr id="7" name="TextBox 6"/>
+          <p:cNvSpPr txBox="1"/>
+          <p:nvPr/>
+        </p:nvSpPr>
+        <p:spPr>
+          <a:xfrm>
+            <a:off x="365760" y="4114800"/>
+            <a:ext cx="8229600" cy="276999"/>
+          </a:xfrm>
+          <a:prstGeom prst="rect">
+            <a:avLst/>
+          </a:prstGeom>
+          <a:noFill/>
+        </p:spPr>
+        <p:txBody>
+          <a:bodyPr wrap="square">
+            <a:spAutoFit/>
+          </a:bodyPr>
+          <a:lstStyle/>
+          <a:p>
+            <a:pPr algn="l"/>
+            <a:r>
+              <a:rPr sz="1200" b="0" dirty="0" err="1">
+                <a:solidFill>
+                  <a:srgbClr val="998888"/>
+                </a:solidFill>
+              </a:rPr>
+              <a:t>Faculdade</a:t>
+            </a:r>
+            <a:r>
+              <a:rPr sz="1200" b="0" dirty="0">
+                <a:solidFill>
+                  <a:srgbClr val="998888"/>
+                </a:solidFill>
+              </a:rPr>
+              <a:t> </a:t>
+            </a:r>
+            <a:r>
+              <a:rPr sz="1200" b="0" dirty="0" err="1">
+                <a:solidFill>
+                  <a:srgbClr val="998888"/>
+                </a:solidFill>
+              </a:rPr>
+              <a:t>Estácio</a:t>
+            </a:r>
+            <a:r>
+              <a:rPr sz="1200" b="0" dirty="0">
+                <a:solidFill>
+                  <a:srgbClr val="998888"/>
+                </a:solidFill>
+              </a:rPr>
+              <a:t>  ·  João Vitor  ·  202</a:t>
+            </a:r>
+            <a:r>
+              <a:rPr lang="pt-BR" sz="1200" b="0" dirty="0">
+                <a:solidFill>
+                  <a:srgbClr val="998888"/>
+                </a:solidFill>
+              </a:rPr>
+              <a:t>6</a:t>
+            </a:r>
+            <a:endParaRPr sz="1200" b="0" dirty="0">
+              <a:solidFill>
+                <a:srgbClr val="998888"/>
+              </a:solidFill>
+            </a:endParaRPr>
           </a:p>
         </p:txBody>
       </p:sp>
@@ -3121,40 +3379,291 @@
 </p:sld>
 </file>
 
-<file path=ppt/slides/slide2.xml><?xml version="1.0" encoding="utf-8"?>
-<p:sld xmlns:a="http://schemas.openxmlformats.org/drawingml/2006/main" xmlns:p="http://schemas.openxmlformats.org/presentationml/2006/main" xmlns:r="http://schemas.openxmlformats.org/officeDocument/2006/relationships">
+<file path=ppt/slides/slide10.xml><?xml version="1.0" encoding="utf-8"?>
+<p:sld xmlns:a="http://schemas.openxmlformats.org/drawingml/2006/main" xmlns:r="http://schemas.openxmlformats.org/officeDocument/2006/relationships" xmlns:p="http://schemas.openxmlformats.org/presentationml/2006/main">
   <p:cSld>
+    <p:bg>
+      <p:bgPr>
+        <a:solidFill>
+          <a:srgbClr val="FAF7F4"/>
+        </a:solidFill>
+        <a:effectLst/>
+      </p:bgPr>
+    </p:bg>
     <p:spTree>
       <p:nvGrpSpPr>
         <p:cNvPr id="1" name=""/>
         <p:cNvGrpSpPr/>
         <p:nvPr/>
       </p:nvGrpSpPr>
-      <p:grpSpPr/>
-      <p:sp>
-        <p:nvSpPr>
-          <p:cNvPr id="2" name="Title 1"/>
-          <p:cNvSpPr>
-            <a:spLocks noGrp="1"/>
-          </p:cNvSpPr>
-          <p:nvPr>
-            <p:ph type="title"/>
-          </p:nvPr>
-        </p:nvSpPr>
-        <p:spPr/>
-        <p:txBody>
-          <a:bodyPr/>
-          <a:lstStyle/>
-          <a:p>
-            <a:r>
-              <a:t>Casos ao longo do tempo</a:t>
+      <p:grpSpPr>
+        <a:xfrm>
+          <a:off x="0" y="0"/>
+          <a:ext cx="0" cy="0"/>
+          <a:chOff x="0" y="0"/>
+          <a:chExt cx="0" cy="0"/>
+        </a:xfrm>
+      </p:grpSpPr>
+      <p:sp>
+        <p:nvSpPr>
+          <p:cNvPr id="2" name="Rectangle 1"/>
+          <p:cNvSpPr/>
+          <p:nvPr/>
+        </p:nvSpPr>
+        <p:spPr>
+          <a:xfrm>
+            <a:off x="0" y="0"/>
+            <a:ext cx="9144000" cy="73152"/>
+          </a:xfrm>
+          <a:prstGeom prst="rect">
+            <a:avLst/>
+          </a:prstGeom>
+          <a:solidFill>
+            <a:srgbClr val="C8382A"/>
+          </a:solidFill>
+          <a:ln>
+            <a:noFill/>
+          </a:ln>
+        </p:spPr>
+        <p:style>
+          <a:lnRef idx="1">
+            <a:schemeClr val="accent1"/>
+          </a:lnRef>
+          <a:fillRef idx="3">
+            <a:schemeClr val="accent1"/>
+          </a:fillRef>
+          <a:effectRef idx="2">
+            <a:schemeClr val="accent1"/>
+          </a:effectRef>
+          <a:fontRef idx="minor">
+            <a:schemeClr val="lt1"/>
+          </a:fontRef>
+        </p:style>
+        <p:txBody>
+          <a:bodyPr rtlCol="0" anchor="ctr"/>
+          <a:lstStyle/>
+          <a:p>
+            <a:pPr algn="ctr"/>
+            <a:endParaRPr/>
+          </a:p>
+        </p:txBody>
+      </p:sp>
+      <p:sp>
+        <p:nvSpPr>
+          <p:cNvPr id="3" name="TextBox 2"/>
+          <p:cNvSpPr txBox="1"/>
+          <p:nvPr/>
+        </p:nvSpPr>
+        <p:spPr>
+          <a:xfrm>
+            <a:off x="365760" y="164592"/>
+            <a:ext cx="8229600" cy="548640"/>
+          </a:xfrm>
+          <a:prstGeom prst="rect">
+            <a:avLst/>
+          </a:prstGeom>
+          <a:noFill/>
+        </p:spPr>
+        <p:txBody>
+          <a:bodyPr wrap="square">
+            <a:spAutoFit/>
+          </a:bodyPr>
+          <a:lstStyle/>
+          <a:p>
+            <a:pPr algn="l"/>
+            <a:r>
+              <a:rPr sz="2200" b="1">
+                <a:solidFill>
+                  <a:srgbClr val="1A1410"/>
+                </a:solidFill>
+              </a:rPr>
+              <a:t>Previsão vs Real — Regressão Linear</a:t>
+            </a:r>
+          </a:p>
+        </p:txBody>
+      </p:sp>
+      <p:sp>
+        <p:nvSpPr>
+          <p:cNvPr id="4" name="TextBox 3"/>
+          <p:cNvSpPr txBox="1"/>
+          <p:nvPr/>
+        </p:nvSpPr>
+        <p:spPr>
+          <a:xfrm>
+            <a:off x="365760" y="685800"/>
+            <a:ext cx="8229600" cy="365760"/>
+          </a:xfrm>
+          <a:prstGeom prst="rect">
+            <a:avLst/>
+          </a:prstGeom>
+          <a:noFill/>
+        </p:spPr>
+        <p:txBody>
+          <a:bodyPr wrap="square">
+            <a:spAutoFit/>
+          </a:bodyPr>
+          <a:lstStyle/>
+          <a:p>
+            <a:pPr algn="l"/>
+            <a:r>
+              <a:rPr sz="1200" b="0">
+                <a:solidFill>
+                  <a:srgbClr val="6B5E58"/>
+                </a:solidFill>
+              </a:rPr>
+              <a:t>Baseline — R² = 0.976 · MAE = 21.9 casos/semana</a:t>
+            </a:r>
+          </a:p>
+        </p:txBody>
+      </p:sp>
+    </p:spTree>
+  </p:cSld>
+  <p:clrMapOvr>
+    <a:masterClrMapping/>
+  </p:clrMapOvr>
+</p:sld>
+</file>
+
+<file path=ppt/slides/slide11.xml><?xml version="1.0" encoding="utf-8"?>
+<p:sld xmlns:a="http://schemas.openxmlformats.org/drawingml/2006/main" xmlns:r="http://schemas.openxmlformats.org/officeDocument/2006/relationships" xmlns:p="http://schemas.openxmlformats.org/presentationml/2006/main">
+  <p:cSld>
+    <p:bg>
+      <p:bgPr>
+        <a:solidFill>
+          <a:srgbClr val="FAF7F4"/>
+        </a:solidFill>
+        <a:effectLst/>
+      </p:bgPr>
+    </p:bg>
+    <p:spTree>
+      <p:nvGrpSpPr>
+        <p:cNvPr id="1" name=""/>
+        <p:cNvGrpSpPr/>
+        <p:nvPr/>
+      </p:nvGrpSpPr>
+      <p:grpSpPr>
+        <a:xfrm>
+          <a:off x="0" y="0"/>
+          <a:ext cx="0" cy="0"/>
+          <a:chOff x="0" y="0"/>
+          <a:chExt cx="0" cy="0"/>
+        </a:xfrm>
+      </p:grpSpPr>
+      <p:sp>
+        <p:nvSpPr>
+          <p:cNvPr id="2" name="Rectangle 1"/>
+          <p:cNvSpPr/>
+          <p:nvPr/>
+        </p:nvSpPr>
+        <p:spPr>
+          <a:xfrm>
+            <a:off x="0" y="0"/>
+            <a:ext cx="9144000" cy="73152"/>
+          </a:xfrm>
+          <a:prstGeom prst="rect">
+            <a:avLst/>
+          </a:prstGeom>
+          <a:solidFill>
+            <a:srgbClr val="C8382A"/>
+          </a:solidFill>
+          <a:ln>
+            <a:noFill/>
+          </a:ln>
+        </p:spPr>
+        <p:style>
+          <a:lnRef idx="1">
+            <a:schemeClr val="accent1"/>
+          </a:lnRef>
+          <a:fillRef idx="3">
+            <a:schemeClr val="accent1"/>
+          </a:fillRef>
+          <a:effectRef idx="2">
+            <a:schemeClr val="accent1"/>
+          </a:effectRef>
+          <a:fontRef idx="minor">
+            <a:schemeClr val="lt1"/>
+          </a:fontRef>
+        </p:style>
+        <p:txBody>
+          <a:bodyPr rtlCol="0" anchor="ctr"/>
+          <a:lstStyle/>
+          <a:p>
+            <a:pPr algn="ctr"/>
+            <a:endParaRPr/>
+          </a:p>
+        </p:txBody>
+      </p:sp>
+      <p:sp>
+        <p:nvSpPr>
+          <p:cNvPr id="3" name="TextBox 2"/>
+          <p:cNvSpPr txBox="1"/>
+          <p:nvPr/>
+        </p:nvSpPr>
+        <p:spPr>
+          <a:xfrm>
+            <a:off x="365760" y="164592"/>
+            <a:ext cx="8229600" cy="548640"/>
+          </a:xfrm>
+          <a:prstGeom prst="rect">
+            <a:avLst/>
+          </a:prstGeom>
+          <a:noFill/>
+        </p:spPr>
+        <p:txBody>
+          <a:bodyPr wrap="square">
+            <a:spAutoFit/>
+          </a:bodyPr>
+          <a:lstStyle/>
+          <a:p>
+            <a:pPr algn="l"/>
+            <a:r>
+              <a:rPr sz="2200" b="1">
+                <a:solidFill>
+                  <a:srgbClr val="1A1410"/>
+                </a:solidFill>
+              </a:rPr>
+              <a:t>Previsão vs Real — Random Forest</a:t>
+            </a:r>
+          </a:p>
+        </p:txBody>
+      </p:sp>
+      <p:sp>
+        <p:nvSpPr>
+          <p:cNvPr id="4" name="TextBox 3"/>
+          <p:cNvSpPr txBox="1"/>
+          <p:nvPr/>
+        </p:nvSpPr>
+        <p:spPr>
+          <a:xfrm>
+            <a:off x="365760" y="685800"/>
+            <a:ext cx="8229600" cy="365760"/>
+          </a:xfrm>
+          <a:prstGeom prst="rect">
+            <a:avLst/>
+          </a:prstGeom>
+          <a:noFill/>
+        </p:spPr>
+        <p:txBody>
+          <a:bodyPr wrap="square">
+            <a:spAutoFit/>
+          </a:bodyPr>
+          <a:lstStyle/>
+          <a:p>
+            <a:pPr algn="l"/>
+            <a:r>
+              <a:rPr sz="1200" b="0">
+                <a:solidFill>
+                  <a:srgbClr val="6B5E58"/>
+                </a:solidFill>
+              </a:rPr>
+              <a:t>200 estimadores — R² = 0.958 · MAE = 17.5 casos/semana</a:t>
             </a:r>
           </a:p>
         </p:txBody>
       </p:sp>
       <p:pic>
         <p:nvPicPr>
-          <p:cNvPr id="3" name="Picture 2" descr="casos_ao_longo_do_tempo.png"/>
+          <p:cNvPr id="5" name="Picture 4" descr="previsao_random_forest.png"/>
           <p:cNvPicPr>
             <a:picLocks noChangeAspect="1"/>
           </p:cNvPicPr>
@@ -3168,8 +3677,8 @@
         </p:blipFill>
         <p:spPr>
           <a:xfrm>
-            <a:off x="914400" y="1828800"/>
-            <a:ext cx="5486400" cy="2985999"/>
+            <a:off x="457200" y="1463040"/>
+            <a:ext cx="8229600" cy="2298286"/>
           </a:xfrm>
           <a:prstGeom prst="rect">
             <a:avLst/>
@@ -3184,40 +3693,146 @@
 </p:sld>
 </file>
 
-<file path=ppt/slides/slide3.xml><?xml version="1.0" encoding="utf-8"?>
-<p:sld xmlns:a="http://schemas.openxmlformats.org/drawingml/2006/main" xmlns:p="http://schemas.openxmlformats.org/presentationml/2006/main" xmlns:r="http://schemas.openxmlformats.org/officeDocument/2006/relationships">
+<file path=ppt/slides/slide12.xml><?xml version="1.0" encoding="utf-8"?>
+<p:sld xmlns:a="http://schemas.openxmlformats.org/drawingml/2006/main" xmlns:r="http://schemas.openxmlformats.org/officeDocument/2006/relationships" xmlns:p="http://schemas.openxmlformats.org/presentationml/2006/main">
   <p:cSld>
+    <p:bg>
+      <p:bgPr>
+        <a:solidFill>
+          <a:srgbClr val="FAF7F4"/>
+        </a:solidFill>
+        <a:effectLst/>
+      </p:bgPr>
+    </p:bg>
     <p:spTree>
       <p:nvGrpSpPr>
         <p:cNvPr id="1" name=""/>
         <p:cNvGrpSpPr/>
         <p:nvPr/>
       </p:nvGrpSpPr>
-      <p:grpSpPr/>
-      <p:sp>
-        <p:nvSpPr>
-          <p:cNvPr id="2" name="Title 1"/>
-          <p:cNvSpPr>
-            <a:spLocks noGrp="1"/>
-          </p:cNvSpPr>
-          <p:nvPr>
-            <p:ph type="title"/>
-          </p:nvPr>
-        </p:nvSpPr>
-        <p:spPr/>
-        <p:txBody>
-          <a:bodyPr/>
-          <a:lstStyle/>
-          <a:p>
-            <a:r>
-              <a:t>Correlação</a:t>
+      <p:grpSpPr>
+        <a:xfrm>
+          <a:off x="0" y="0"/>
+          <a:ext cx="0" cy="0"/>
+          <a:chOff x="0" y="0"/>
+          <a:chExt cx="0" cy="0"/>
+        </a:xfrm>
+      </p:grpSpPr>
+      <p:sp>
+        <p:nvSpPr>
+          <p:cNvPr id="2" name="Rectangle 1"/>
+          <p:cNvSpPr/>
+          <p:nvPr/>
+        </p:nvSpPr>
+        <p:spPr>
+          <a:xfrm>
+            <a:off x="0" y="0"/>
+            <a:ext cx="9144000" cy="73152"/>
+          </a:xfrm>
+          <a:prstGeom prst="rect">
+            <a:avLst/>
+          </a:prstGeom>
+          <a:solidFill>
+            <a:srgbClr val="C8382A"/>
+          </a:solidFill>
+          <a:ln>
+            <a:noFill/>
+          </a:ln>
+        </p:spPr>
+        <p:style>
+          <a:lnRef idx="1">
+            <a:schemeClr val="accent1"/>
+          </a:lnRef>
+          <a:fillRef idx="3">
+            <a:schemeClr val="accent1"/>
+          </a:fillRef>
+          <a:effectRef idx="2">
+            <a:schemeClr val="accent1"/>
+          </a:effectRef>
+          <a:fontRef idx="minor">
+            <a:schemeClr val="lt1"/>
+          </a:fontRef>
+        </p:style>
+        <p:txBody>
+          <a:bodyPr rtlCol="0" anchor="ctr"/>
+          <a:lstStyle/>
+          <a:p>
+            <a:pPr algn="ctr"/>
+            <a:endParaRPr/>
+          </a:p>
+        </p:txBody>
+      </p:sp>
+      <p:sp>
+        <p:nvSpPr>
+          <p:cNvPr id="3" name="TextBox 2"/>
+          <p:cNvSpPr txBox="1"/>
+          <p:nvPr/>
+        </p:nvSpPr>
+        <p:spPr>
+          <a:xfrm>
+            <a:off x="365760" y="164592"/>
+            <a:ext cx="8229600" cy="548640"/>
+          </a:xfrm>
+          <a:prstGeom prst="rect">
+            <a:avLst/>
+          </a:prstGeom>
+          <a:noFill/>
+        </p:spPr>
+        <p:txBody>
+          <a:bodyPr wrap="square">
+            <a:spAutoFit/>
+          </a:bodyPr>
+          <a:lstStyle/>
+          <a:p>
+            <a:pPr algn="l"/>
+            <a:r>
+              <a:rPr sz="2200" b="1">
+                <a:solidFill>
+                  <a:srgbClr val="1A1410"/>
+                </a:solidFill>
+              </a:rPr>
+              <a:t>Previsão vs Real — XGBoost ★</a:t>
+            </a:r>
+          </a:p>
+        </p:txBody>
+      </p:sp>
+      <p:sp>
+        <p:nvSpPr>
+          <p:cNvPr id="4" name="TextBox 3"/>
+          <p:cNvSpPr txBox="1"/>
+          <p:nvPr/>
+        </p:nvSpPr>
+        <p:spPr>
+          <a:xfrm>
+            <a:off x="365760" y="685800"/>
+            <a:ext cx="8229600" cy="365760"/>
+          </a:xfrm>
+          <a:prstGeom prst="rect">
+            <a:avLst/>
+          </a:prstGeom>
+          <a:noFill/>
+        </p:spPr>
+        <p:txBody>
+          <a:bodyPr wrap="square">
+            <a:spAutoFit/>
+          </a:bodyPr>
+          <a:lstStyle/>
+          <a:p>
+            <a:pPr algn="l"/>
+            <a:r>
+              <a:rPr sz="1200" b="0">
+                <a:solidFill>
+                  <a:srgbClr val="6B5E58"/>
+                </a:solidFill>
+              </a:rPr>
+              <a:t>Melhor modelo — R² = 0.964 · MAE = 14.3 casos/semana</a:t>
             </a:r>
           </a:p>
         </p:txBody>
       </p:sp>
       <p:pic>
         <p:nvPicPr>
-          <p:cNvPr id="3" name="Picture 2" descr="correlacao.png"/>
+          <p:cNvPr id="5" name="Picture 4" descr="previsao_xgboost.png"/>
           <p:cNvPicPr>
             <a:picLocks noChangeAspect="1"/>
           </p:cNvPicPr>
@@ -3231,8 +3846,8 @@
         </p:blipFill>
         <p:spPr>
           <a:xfrm>
-            <a:off x="914400" y="1828800"/>
-            <a:ext cx="5486400" cy="5486400"/>
+            <a:off x="457200" y="1463040"/>
+            <a:ext cx="8229600" cy="2298286"/>
           </a:xfrm>
           <a:prstGeom prst="rect">
             <a:avLst/>
@@ -3247,40 +3862,826 @@
 </p:sld>
 </file>
 
-<file path=ppt/slides/slide4.xml><?xml version="1.0" encoding="utf-8"?>
-<p:sld xmlns:a="http://schemas.openxmlformats.org/drawingml/2006/main" xmlns:p="http://schemas.openxmlformats.org/presentationml/2006/main" xmlns:r="http://schemas.openxmlformats.org/officeDocument/2006/relationships">
+<file path=ppt/slides/slide13.xml><?xml version="1.0" encoding="utf-8"?>
+<p:sld xmlns:a="http://schemas.openxmlformats.org/drawingml/2006/main" xmlns:r="http://schemas.openxmlformats.org/officeDocument/2006/relationships" xmlns:p="http://schemas.openxmlformats.org/presentationml/2006/main">
   <p:cSld>
+    <p:bg>
+      <p:bgPr>
+        <a:solidFill>
+          <a:srgbClr val="C8382A"/>
+        </a:solidFill>
+        <a:effectLst/>
+      </p:bgPr>
+    </p:bg>
     <p:spTree>
       <p:nvGrpSpPr>
         <p:cNvPr id="1" name=""/>
         <p:cNvGrpSpPr/>
         <p:nvPr/>
       </p:nvGrpSpPr>
-      <p:grpSpPr/>
-      <p:sp>
-        <p:nvSpPr>
-          <p:cNvPr id="2" name="Title 1"/>
-          <p:cNvSpPr>
-            <a:spLocks noGrp="1"/>
-          </p:cNvSpPr>
-          <p:nvPr>
-            <p:ph type="title"/>
-          </p:nvPr>
-        </p:nvSpPr>
-        <p:spPr/>
-        <p:txBody>
-          <a:bodyPr/>
-          <a:lstStyle/>
-          <a:p>
-            <a:r>
-              <a:t>Importância das Variáveis</a:t>
+      <p:grpSpPr>
+        <a:xfrm>
+          <a:off x="0" y="0"/>
+          <a:ext cx="0" cy="0"/>
+          <a:chOff x="0" y="0"/>
+          <a:chExt cx="0" cy="0"/>
+        </a:xfrm>
+      </p:grpSpPr>
+      <p:sp>
+        <p:nvSpPr>
+          <p:cNvPr id="2" name="Rectangle 1"/>
+          <p:cNvSpPr/>
+          <p:nvPr/>
+        </p:nvSpPr>
+        <p:spPr>
+          <a:xfrm>
+            <a:off x="0" y="0"/>
+            <a:ext cx="109728" cy="6858000"/>
+          </a:xfrm>
+          <a:prstGeom prst="rect">
+            <a:avLst/>
+          </a:prstGeom>
+          <a:solidFill>
+            <a:srgbClr val="AA281C"/>
+          </a:solidFill>
+          <a:ln>
+            <a:noFill/>
+          </a:ln>
+        </p:spPr>
+        <p:style>
+          <a:lnRef idx="1">
+            <a:schemeClr val="accent1"/>
+          </a:lnRef>
+          <a:fillRef idx="3">
+            <a:schemeClr val="accent1"/>
+          </a:fillRef>
+          <a:effectRef idx="2">
+            <a:schemeClr val="accent1"/>
+          </a:effectRef>
+          <a:fontRef idx="minor">
+            <a:schemeClr val="lt1"/>
+          </a:fontRef>
+        </p:style>
+        <p:txBody>
+          <a:bodyPr rtlCol="0" anchor="ctr"/>
+          <a:lstStyle/>
+          <a:p>
+            <a:pPr algn="ctr"/>
+            <a:endParaRPr/>
+          </a:p>
+        </p:txBody>
+      </p:sp>
+      <p:sp>
+        <p:nvSpPr>
+          <p:cNvPr id="3" name="TextBox 2"/>
+          <p:cNvSpPr txBox="1"/>
+          <p:nvPr/>
+        </p:nvSpPr>
+        <p:spPr>
+          <a:xfrm>
+            <a:off x="274320" y="274320"/>
+            <a:ext cx="1371600" cy="1371600"/>
+          </a:xfrm>
+          <a:prstGeom prst="rect">
+            <a:avLst/>
+          </a:prstGeom>
+          <a:noFill/>
+        </p:spPr>
+        <p:txBody>
+          <a:bodyPr wrap="square">
+            <a:spAutoFit/>
+          </a:bodyPr>
+          <a:lstStyle/>
+          <a:p>
+            <a:pPr algn="l"/>
+            <a:r>
+              <a:rPr sz="6000" b="0">
+                <a:solidFill>
+                  <a:srgbClr val="FFFFFF"/>
+                </a:solidFill>
+              </a:rPr>
+              <a:t>🦟</a:t>
+            </a:r>
+          </a:p>
+        </p:txBody>
+      </p:sp>
+      <p:sp>
+        <p:nvSpPr>
+          <p:cNvPr id="4" name="TextBox 3"/>
+          <p:cNvSpPr txBox="1"/>
+          <p:nvPr/>
+        </p:nvSpPr>
+        <p:spPr>
+          <a:xfrm>
+            <a:off x="365760" y="1371600"/>
+            <a:ext cx="8229600" cy="822960"/>
+          </a:xfrm>
+          <a:prstGeom prst="rect">
+            <a:avLst/>
+          </a:prstGeom>
+          <a:noFill/>
+        </p:spPr>
+        <p:txBody>
+          <a:bodyPr wrap="square">
+            <a:spAutoFit/>
+          </a:bodyPr>
+          <a:lstStyle/>
+          <a:p>
+            <a:pPr algn="l"/>
+            <a:r>
+              <a:rPr sz="3600" b="1">
+                <a:solidFill>
+                  <a:srgbClr val="FFFFFF"/>
+                </a:solidFill>
+              </a:rPr>
+              <a:t>Conclusão</a:t>
+            </a:r>
+          </a:p>
+        </p:txBody>
+      </p:sp>
+      <p:sp>
+        <p:nvSpPr>
+          <p:cNvPr id="5" name="Rectangle 4"/>
+          <p:cNvSpPr/>
+          <p:nvPr/>
+        </p:nvSpPr>
+        <p:spPr>
+          <a:xfrm>
+            <a:off x="365760" y="2331720"/>
+            <a:ext cx="109728" cy="109728"/>
+          </a:xfrm>
+          <a:prstGeom prst="rect">
+            <a:avLst/>
+          </a:prstGeom>
+          <a:solidFill>
+            <a:srgbClr val="FFFFFF"/>
+          </a:solidFill>
+          <a:ln>
+            <a:noFill/>
+          </a:ln>
+        </p:spPr>
+        <p:style>
+          <a:lnRef idx="1">
+            <a:schemeClr val="accent1"/>
+          </a:lnRef>
+          <a:fillRef idx="3">
+            <a:schemeClr val="accent1"/>
+          </a:fillRef>
+          <a:effectRef idx="2">
+            <a:schemeClr val="accent1"/>
+          </a:effectRef>
+          <a:fontRef idx="minor">
+            <a:schemeClr val="lt1"/>
+          </a:fontRef>
+        </p:style>
+        <p:txBody>
+          <a:bodyPr rtlCol="0" anchor="ctr"/>
+          <a:lstStyle/>
+          <a:p>
+            <a:pPr algn="ctr"/>
+            <a:endParaRPr/>
+          </a:p>
+        </p:txBody>
+      </p:sp>
+      <p:sp>
+        <p:nvSpPr>
+          <p:cNvPr id="6" name="TextBox 5"/>
+          <p:cNvSpPr txBox="1"/>
+          <p:nvPr/>
+        </p:nvSpPr>
+        <p:spPr>
+          <a:xfrm>
+            <a:off x="594360" y="2267712"/>
+            <a:ext cx="8229600" cy="457200"/>
+          </a:xfrm>
+          <a:prstGeom prst="rect">
+            <a:avLst/>
+          </a:prstGeom>
+          <a:noFill/>
+        </p:spPr>
+        <p:txBody>
+          <a:bodyPr wrap="square">
+            <a:spAutoFit/>
+          </a:bodyPr>
+          <a:lstStyle/>
+          <a:p>
+            <a:pPr algn="l"/>
+            <a:r>
+              <a:rPr sz="1400" b="0">
+                <a:solidFill>
+                  <a:srgbClr val="FFFFFF"/>
+                </a:solidFill>
+              </a:rPr>
+              <a:t>R² acima de 0.96 — alta precisão preditiva</a:t>
+            </a:r>
+          </a:p>
+        </p:txBody>
+      </p:sp>
+      <p:sp>
+        <p:nvSpPr>
+          <p:cNvPr id="7" name="Rectangle 6"/>
+          <p:cNvSpPr/>
+          <p:nvPr/>
+        </p:nvSpPr>
+        <p:spPr>
+          <a:xfrm>
+            <a:off x="365760" y="2990087"/>
+            <a:ext cx="109728" cy="109728"/>
+          </a:xfrm>
+          <a:prstGeom prst="rect">
+            <a:avLst/>
+          </a:prstGeom>
+          <a:solidFill>
+            <a:srgbClr val="FFFFFF"/>
+          </a:solidFill>
+          <a:ln>
+            <a:noFill/>
+          </a:ln>
+        </p:spPr>
+        <p:style>
+          <a:lnRef idx="1">
+            <a:schemeClr val="accent1"/>
+          </a:lnRef>
+          <a:fillRef idx="3">
+            <a:schemeClr val="accent1"/>
+          </a:fillRef>
+          <a:effectRef idx="2">
+            <a:schemeClr val="accent1"/>
+          </a:effectRef>
+          <a:fontRef idx="minor">
+            <a:schemeClr val="lt1"/>
+          </a:fontRef>
+        </p:style>
+        <p:txBody>
+          <a:bodyPr rtlCol="0" anchor="ctr"/>
+          <a:lstStyle/>
+          <a:p>
+            <a:pPr algn="ctr"/>
+            <a:endParaRPr/>
+          </a:p>
+        </p:txBody>
+      </p:sp>
+      <p:sp>
+        <p:nvSpPr>
+          <p:cNvPr id="8" name="TextBox 7"/>
+          <p:cNvSpPr txBox="1"/>
+          <p:nvPr/>
+        </p:nvSpPr>
+        <p:spPr>
+          <a:xfrm>
+            <a:off x="594360" y="2926080"/>
+            <a:ext cx="8229600" cy="457200"/>
+          </a:xfrm>
+          <a:prstGeom prst="rect">
+            <a:avLst/>
+          </a:prstGeom>
+          <a:noFill/>
+        </p:spPr>
+        <p:txBody>
+          <a:bodyPr wrap="square">
+            <a:spAutoFit/>
+          </a:bodyPr>
+          <a:lstStyle/>
+          <a:p>
+            <a:pPr algn="l"/>
+            <a:r>
+              <a:rPr sz="1400" b="0">
+                <a:solidFill>
+                  <a:srgbClr val="FFFFFF"/>
+                </a:solidFill>
+              </a:rPr>
+              <a:t>51.429 casos reais confirmados da Prefeitura do Recife</a:t>
+            </a:r>
+          </a:p>
+        </p:txBody>
+      </p:sp>
+      <p:sp>
+        <p:nvSpPr>
+          <p:cNvPr id="9" name="Rectangle 8"/>
+          <p:cNvSpPr/>
+          <p:nvPr/>
+        </p:nvSpPr>
+        <p:spPr>
+          <a:xfrm>
+            <a:off x="365760" y="3648456"/>
+            <a:ext cx="109728" cy="109728"/>
+          </a:xfrm>
+          <a:prstGeom prst="rect">
+            <a:avLst/>
+          </a:prstGeom>
+          <a:solidFill>
+            <a:srgbClr val="FFFFFF"/>
+          </a:solidFill>
+          <a:ln>
+            <a:noFill/>
+          </a:ln>
+        </p:spPr>
+        <p:style>
+          <a:lnRef idx="1">
+            <a:schemeClr val="accent1"/>
+          </a:lnRef>
+          <a:fillRef idx="3">
+            <a:schemeClr val="accent1"/>
+          </a:fillRef>
+          <a:effectRef idx="2">
+            <a:schemeClr val="accent1"/>
+          </a:effectRef>
+          <a:fontRef idx="minor">
+            <a:schemeClr val="lt1"/>
+          </a:fontRef>
+        </p:style>
+        <p:txBody>
+          <a:bodyPr rtlCol="0" anchor="ctr"/>
+          <a:lstStyle/>
+          <a:p>
+            <a:pPr algn="ctr"/>
+            <a:endParaRPr/>
+          </a:p>
+        </p:txBody>
+      </p:sp>
+      <p:sp>
+        <p:nvSpPr>
+          <p:cNvPr id="10" name="TextBox 9"/>
+          <p:cNvSpPr txBox="1"/>
+          <p:nvPr/>
+        </p:nvSpPr>
+        <p:spPr>
+          <a:xfrm>
+            <a:off x="594360" y="3584448"/>
+            <a:ext cx="8229600" cy="457200"/>
+          </a:xfrm>
+          <a:prstGeom prst="rect">
+            <a:avLst/>
+          </a:prstGeom>
+          <a:noFill/>
+        </p:spPr>
+        <p:txBody>
+          <a:bodyPr wrap="square">
+            <a:spAutoFit/>
+          </a:bodyPr>
+          <a:lstStyle/>
+          <a:p>
+            <a:pPr algn="l"/>
+            <a:r>
+              <a:rPr sz="1400" b="0">
+                <a:solidFill>
+                  <a:srgbClr val="FFFFFF"/>
+                </a:solidFill>
+              </a:rPr>
+              <a:t>Sistema completo: ingestão → ML → API → frontend → mapa</a:t>
+            </a:r>
+          </a:p>
+        </p:txBody>
+      </p:sp>
+      <p:sp>
+        <p:nvSpPr>
+          <p:cNvPr id="11" name="Rectangle 10"/>
+          <p:cNvSpPr/>
+          <p:nvPr/>
+        </p:nvSpPr>
+        <p:spPr>
+          <a:xfrm>
+            <a:off x="365760" y="4306824"/>
+            <a:ext cx="109728" cy="109728"/>
+          </a:xfrm>
+          <a:prstGeom prst="rect">
+            <a:avLst/>
+          </a:prstGeom>
+          <a:solidFill>
+            <a:srgbClr val="FFFFFF"/>
+          </a:solidFill>
+          <a:ln>
+            <a:noFill/>
+          </a:ln>
+        </p:spPr>
+        <p:style>
+          <a:lnRef idx="1">
+            <a:schemeClr val="accent1"/>
+          </a:lnRef>
+          <a:fillRef idx="3">
+            <a:schemeClr val="accent1"/>
+          </a:fillRef>
+          <a:effectRef idx="2">
+            <a:schemeClr val="accent1"/>
+          </a:effectRef>
+          <a:fontRef idx="minor">
+            <a:schemeClr val="lt1"/>
+          </a:fontRef>
+        </p:style>
+        <p:txBody>
+          <a:bodyPr rtlCol="0" anchor="ctr"/>
+          <a:lstStyle/>
+          <a:p>
+            <a:pPr algn="ctr"/>
+            <a:endParaRPr/>
+          </a:p>
+        </p:txBody>
+      </p:sp>
+      <p:sp>
+        <p:nvSpPr>
+          <p:cNvPr id="12" name="TextBox 11"/>
+          <p:cNvSpPr txBox="1"/>
+          <p:nvPr/>
+        </p:nvSpPr>
+        <p:spPr>
+          <a:xfrm>
+            <a:off x="594360" y="4242816"/>
+            <a:ext cx="8229600" cy="457200"/>
+          </a:xfrm>
+          <a:prstGeom prst="rect">
+            <a:avLst/>
+          </a:prstGeom>
+          <a:noFill/>
+        </p:spPr>
+        <p:txBody>
+          <a:bodyPr wrap="square">
+            <a:spAutoFit/>
+          </a:bodyPr>
+          <a:lstStyle/>
+          <a:p>
+            <a:pPr algn="l"/>
+            <a:r>
+              <a:rPr sz="1400" b="0">
+                <a:solidFill>
+                  <a:srgbClr val="FFFFFF"/>
+                </a:solidFill>
+              </a:rPr>
+              <a:t>Potencial real de apoio à Vigilância Epidemiológica</a:t>
+            </a:r>
+          </a:p>
+        </p:txBody>
+      </p:sp>
+      <p:sp>
+        <p:nvSpPr>
+          <p:cNvPr id="13" name="Rectangle 12"/>
+          <p:cNvSpPr/>
+          <p:nvPr/>
+        </p:nvSpPr>
+        <p:spPr>
+          <a:xfrm>
+            <a:off x="0" y="6217920"/>
+            <a:ext cx="9144000" cy="640080"/>
+          </a:xfrm>
+          <a:prstGeom prst="rect">
+            <a:avLst/>
+          </a:prstGeom>
+          <a:solidFill>
+            <a:srgbClr val="AA281C"/>
+          </a:solidFill>
+          <a:ln>
+            <a:noFill/>
+          </a:ln>
+        </p:spPr>
+        <p:style>
+          <a:lnRef idx="1">
+            <a:schemeClr val="accent1"/>
+          </a:lnRef>
+          <a:fillRef idx="3">
+            <a:schemeClr val="accent1"/>
+          </a:fillRef>
+          <a:effectRef idx="2">
+            <a:schemeClr val="accent1"/>
+          </a:effectRef>
+          <a:fontRef idx="minor">
+            <a:schemeClr val="lt1"/>
+          </a:fontRef>
+        </p:style>
+        <p:txBody>
+          <a:bodyPr rtlCol="0" anchor="ctr"/>
+          <a:lstStyle/>
+          <a:p>
+            <a:pPr algn="ctr"/>
+            <a:endParaRPr/>
+          </a:p>
+        </p:txBody>
+      </p:sp>
+      <p:sp>
+        <p:nvSpPr>
+          <p:cNvPr id="14" name="TextBox 13"/>
+          <p:cNvSpPr txBox="1"/>
+          <p:nvPr/>
+        </p:nvSpPr>
+        <p:spPr>
+          <a:xfrm>
+            <a:off x="274320" y="6263640"/>
+            <a:ext cx="8595360" cy="457200"/>
+          </a:xfrm>
+          <a:prstGeom prst="rect">
+            <a:avLst/>
+          </a:prstGeom>
+          <a:noFill/>
+        </p:spPr>
+        <p:txBody>
+          <a:bodyPr wrap="square">
+            <a:spAutoFit/>
+          </a:bodyPr>
+          <a:lstStyle/>
+          <a:p>
+            <a:pPr algn="ctr"/>
+            <a:r>
+              <a:rPr sz="1100" b="0">
+                <a:solidFill>
+                  <a:srgbClr val="FFCCCC"/>
+                </a:solidFill>
+              </a:rPr>
+              <a:t>github.com/JoaoVitorXdz/dengue-recife  ·  Faculdade Estácio  ·  João Vitor  ·  2025</a:t>
+            </a:r>
+          </a:p>
+        </p:txBody>
+      </p:sp>
+    </p:spTree>
+  </p:cSld>
+  <p:clrMapOvr>
+    <a:masterClrMapping/>
+  </p:clrMapOvr>
+</p:sld>
+</file>
+
+<file path=ppt/slides/slide2.xml><?xml version="1.0" encoding="utf-8"?>
+<p:sld xmlns:a="http://schemas.openxmlformats.org/drawingml/2006/main" xmlns:r="http://schemas.openxmlformats.org/officeDocument/2006/relationships" xmlns:p="http://schemas.openxmlformats.org/presentationml/2006/main">
+  <p:cSld>
+    <p:bg>
+      <p:bgPr>
+        <a:solidFill>
+          <a:srgbClr val="C8382A"/>
+        </a:solidFill>
+        <a:effectLst/>
+      </p:bgPr>
+    </p:bg>
+    <p:spTree>
+      <p:nvGrpSpPr>
+        <p:cNvPr id="1" name=""/>
+        <p:cNvGrpSpPr/>
+        <p:nvPr/>
+      </p:nvGrpSpPr>
+      <p:grpSpPr>
+        <a:xfrm>
+          <a:off x="0" y="0"/>
+          <a:ext cx="0" cy="0"/>
+          <a:chOff x="0" y="0"/>
+          <a:chExt cx="0" cy="0"/>
+        </a:xfrm>
+      </p:grpSpPr>
+      <p:sp>
+        <p:nvSpPr>
+          <p:cNvPr id="2" name="Rectangle 1"/>
+          <p:cNvSpPr/>
+          <p:nvPr/>
+        </p:nvSpPr>
+        <p:spPr>
+          <a:xfrm>
+            <a:off x="0" y="0"/>
+            <a:ext cx="109728" cy="6858000"/>
+          </a:xfrm>
+          <a:prstGeom prst="rect">
+            <a:avLst/>
+          </a:prstGeom>
+          <a:solidFill>
+            <a:srgbClr val="AA281C"/>
+          </a:solidFill>
+          <a:ln>
+            <a:noFill/>
+          </a:ln>
+        </p:spPr>
+        <p:style>
+          <a:lnRef idx="1">
+            <a:schemeClr val="accent1"/>
+          </a:lnRef>
+          <a:fillRef idx="3">
+            <a:schemeClr val="accent1"/>
+          </a:fillRef>
+          <a:effectRef idx="2">
+            <a:schemeClr val="accent1"/>
+          </a:effectRef>
+          <a:fontRef idx="minor">
+            <a:schemeClr val="lt1"/>
+          </a:fontRef>
+        </p:style>
+        <p:txBody>
+          <a:bodyPr rtlCol="0" anchor="ctr"/>
+          <a:lstStyle/>
+          <a:p>
+            <a:pPr algn="ctr"/>
+            <a:endParaRPr/>
+          </a:p>
+        </p:txBody>
+      </p:sp>
+      <p:sp>
+        <p:nvSpPr>
+          <p:cNvPr id="3" name="TextBox 2"/>
+          <p:cNvSpPr txBox="1"/>
+          <p:nvPr/>
+        </p:nvSpPr>
+        <p:spPr>
+          <a:xfrm>
+            <a:off x="457200" y="2286000"/>
+            <a:ext cx="8229600" cy="1097280"/>
+          </a:xfrm>
+          <a:prstGeom prst="rect">
+            <a:avLst/>
+          </a:prstGeom>
+          <a:noFill/>
+        </p:spPr>
+        <p:txBody>
+          <a:bodyPr wrap="square">
+            <a:spAutoFit/>
+          </a:bodyPr>
+          <a:lstStyle/>
+          <a:p>
+            <a:pPr algn="ctr"/>
+            <a:r>
+              <a:rPr sz="3600" b="1">
+                <a:solidFill>
+                  <a:srgbClr val="FFFFFF"/>
+                </a:solidFill>
+              </a:rPr>
+              <a:t>01. Base de Dados</a:t>
+            </a:r>
+          </a:p>
+        </p:txBody>
+      </p:sp>
+      <p:sp>
+        <p:nvSpPr>
+          <p:cNvPr id="4" name="TextBox 3"/>
+          <p:cNvSpPr txBox="1"/>
+          <p:nvPr/>
+        </p:nvSpPr>
+        <p:spPr>
+          <a:xfrm>
+            <a:off x="457200" y="3291840"/>
+            <a:ext cx="8229600" cy="548640"/>
+          </a:xfrm>
+          <a:prstGeom prst="rect">
+            <a:avLst/>
+          </a:prstGeom>
+          <a:noFill/>
+        </p:spPr>
+        <p:txBody>
+          <a:bodyPr wrap="square">
+            <a:spAutoFit/>
+          </a:bodyPr>
+          <a:lstStyle/>
+          <a:p>
+            <a:pPr algn="ctr"/>
+            <a:r>
+              <a:rPr sz="1400" b="0">
+                <a:solidFill>
+                  <a:srgbClr val="FFCCCC"/>
+                </a:solidFill>
+              </a:rPr>
+              <a:t>520 semanas · 51.429 casos reais · 94 bairros de Recife</a:t>
+            </a:r>
+          </a:p>
+        </p:txBody>
+      </p:sp>
+    </p:spTree>
+  </p:cSld>
+  <p:clrMapOvr>
+    <a:masterClrMapping/>
+  </p:clrMapOvr>
+</p:sld>
+</file>
+
+<file path=ppt/slides/slide3.xml><?xml version="1.0" encoding="utf-8"?>
+<p:sld xmlns:a="http://schemas.openxmlformats.org/drawingml/2006/main" xmlns:r="http://schemas.openxmlformats.org/officeDocument/2006/relationships" xmlns:p="http://schemas.openxmlformats.org/presentationml/2006/main">
+  <p:cSld>
+    <p:bg>
+      <p:bgPr>
+        <a:solidFill>
+          <a:srgbClr val="FAF7F4"/>
+        </a:solidFill>
+        <a:effectLst/>
+      </p:bgPr>
+    </p:bg>
+    <p:spTree>
+      <p:nvGrpSpPr>
+        <p:cNvPr id="1" name=""/>
+        <p:cNvGrpSpPr/>
+        <p:nvPr/>
+      </p:nvGrpSpPr>
+      <p:grpSpPr>
+        <a:xfrm>
+          <a:off x="0" y="0"/>
+          <a:ext cx="0" cy="0"/>
+          <a:chOff x="0" y="0"/>
+          <a:chExt cx="0" cy="0"/>
+        </a:xfrm>
+      </p:grpSpPr>
+      <p:sp>
+        <p:nvSpPr>
+          <p:cNvPr id="2" name="Rectangle 1"/>
+          <p:cNvSpPr/>
+          <p:nvPr/>
+        </p:nvSpPr>
+        <p:spPr>
+          <a:xfrm>
+            <a:off x="0" y="0"/>
+            <a:ext cx="9144000" cy="73152"/>
+          </a:xfrm>
+          <a:prstGeom prst="rect">
+            <a:avLst/>
+          </a:prstGeom>
+          <a:solidFill>
+            <a:srgbClr val="C8382A"/>
+          </a:solidFill>
+          <a:ln>
+            <a:noFill/>
+          </a:ln>
+        </p:spPr>
+        <p:style>
+          <a:lnRef idx="1">
+            <a:schemeClr val="accent1"/>
+          </a:lnRef>
+          <a:fillRef idx="3">
+            <a:schemeClr val="accent1"/>
+          </a:fillRef>
+          <a:effectRef idx="2">
+            <a:schemeClr val="accent1"/>
+          </a:effectRef>
+          <a:fontRef idx="minor">
+            <a:schemeClr val="lt1"/>
+          </a:fontRef>
+        </p:style>
+        <p:txBody>
+          <a:bodyPr rtlCol="0" anchor="ctr"/>
+          <a:lstStyle/>
+          <a:p>
+            <a:pPr algn="ctr"/>
+            <a:endParaRPr/>
+          </a:p>
+        </p:txBody>
+      </p:sp>
+      <p:sp>
+        <p:nvSpPr>
+          <p:cNvPr id="3" name="TextBox 2"/>
+          <p:cNvSpPr txBox="1"/>
+          <p:nvPr/>
+        </p:nvSpPr>
+        <p:spPr>
+          <a:xfrm>
+            <a:off x="365760" y="164592"/>
+            <a:ext cx="8229600" cy="548640"/>
+          </a:xfrm>
+          <a:prstGeom prst="rect">
+            <a:avLst/>
+          </a:prstGeom>
+          <a:noFill/>
+        </p:spPr>
+        <p:txBody>
+          <a:bodyPr wrap="square">
+            <a:spAutoFit/>
+          </a:bodyPr>
+          <a:lstStyle/>
+          <a:p>
+            <a:pPr algn="l"/>
+            <a:r>
+              <a:rPr sz="2200" b="1">
+                <a:solidFill>
+                  <a:srgbClr val="1A1410"/>
+                </a:solidFill>
+              </a:rPr>
+              <a:t>Casos estimados de dengue — Recife (2015–2024)</a:t>
+            </a:r>
+          </a:p>
+        </p:txBody>
+      </p:sp>
+      <p:sp>
+        <p:nvSpPr>
+          <p:cNvPr id="4" name="TextBox 3"/>
+          <p:cNvSpPr txBox="1"/>
+          <p:nvPr/>
+        </p:nvSpPr>
+        <p:spPr>
+          <a:xfrm>
+            <a:off x="365760" y="685800"/>
+            <a:ext cx="8229600" cy="365760"/>
+          </a:xfrm>
+          <a:prstGeom prst="rect">
+            <a:avLst/>
+          </a:prstGeom>
+          <a:noFill/>
+        </p:spPr>
+        <p:txBody>
+          <a:bodyPr wrap="square">
+            <a:spAutoFit/>
+          </a:bodyPr>
+          <a:lstStyle/>
+          <a:p>
+            <a:pPr algn="l"/>
+            <a:r>
+              <a:rPr sz="1200" b="0">
+                <a:solidFill>
+                  <a:srgbClr val="6B5E58"/>
+                </a:solidFill>
+              </a:rPr>
+              <a:t>Série temporal semanal com picos sazonais claros</a:t>
             </a:r>
           </a:p>
         </p:txBody>
       </p:sp>
       <p:pic>
         <p:nvPicPr>
-          <p:cNvPr id="3" name="Picture 2" descr="importancia_features.png"/>
+          <p:cNvPr id="5" name="Picture 4" descr="casos_ao_longo_do_tempo.png"/>
           <p:cNvPicPr>
             <a:picLocks noChangeAspect="1"/>
           </p:cNvPicPr>
@@ -3294,8 +4695,8 @@
         </p:blipFill>
         <p:spPr>
           <a:xfrm>
-            <a:off x="914400" y="1828800"/>
-            <a:ext cx="5486400" cy="3429000"/>
+            <a:off x="457200" y="1463040"/>
+            <a:ext cx="8229600" cy="2684769"/>
           </a:xfrm>
           <a:prstGeom prst="rect">
             <a:avLst/>
@@ -3310,40 +4711,214 @@
 </p:sld>
 </file>
 
-<file path=ppt/slides/slide5.xml><?xml version="1.0" encoding="utf-8"?>
-<p:sld xmlns:a="http://schemas.openxmlformats.org/drawingml/2006/main" xmlns:p="http://schemas.openxmlformats.org/presentationml/2006/main" xmlns:r="http://schemas.openxmlformats.org/officeDocument/2006/relationships">
+<file path=ppt/slides/slide4.xml><?xml version="1.0" encoding="utf-8"?>
+<p:sld xmlns:a="http://schemas.openxmlformats.org/drawingml/2006/main" xmlns:r="http://schemas.openxmlformats.org/officeDocument/2006/relationships" xmlns:p="http://schemas.openxmlformats.org/presentationml/2006/main">
   <p:cSld>
+    <p:bg>
+      <p:bgPr>
+        <a:solidFill>
+          <a:srgbClr val="FAF7F4"/>
+        </a:solidFill>
+        <a:effectLst/>
+      </p:bgPr>
+    </p:bg>
     <p:spTree>
       <p:nvGrpSpPr>
         <p:cNvPr id="1" name=""/>
         <p:cNvGrpSpPr/>
         <p:nvPr/>
       </p:nvGrpSpPr>
-      <p:grpSpPr/>
-      <p:sp>
-        <p:nvSpPr>
-          <p:cNvPr id="2" name="Title 1"/>
-          <p:cNvSpPr>
-            <a:spLocks noGrp="1"/>
-          </p:cNvSpPr>
-          <p:nvPr>
-            <p:ph type="title"/>
-          </p:nvPr>
-        </p:nvSpPr>
-        <p:spPr/>
-        <p:txBody>
-          <a:bodyPr/>
-          <a:lstStyle/>
-          <a:p>
-            <a:r>
-              <a:t>Previsão XGBoost</a:t>
+      <p:grpSpPr>
+        <a:xfrm>
+          <a:off x="0" y="0"/>
+          <a:ext cx="0" cy="0"/>
+          <a:chOff x="0" y="0"/>
+          <a:chExt cx="0" cy="0"/>
+        </a:xfrm>
+      </p:grpSpPr>
+      <p:sp>
+        <p:nvSpPr>
+          <p:cNvPr id="2" name="Rectangle 1"/>
+          <p:cNvSpPr/>
+          <p:nvPr/>
+        </p:nvSpPr>
+        <p:spPr>
+          <a:xfrm>
+            <a:off x="0" y="0"/>
+            <a:ext cx="9144000" cy="73152"/>
+          </a:xfrm>
+          <a:prstGeom prst="rect">
+            <a:avLst/>
+          </a:prstGeom>
+          <a:solidFill>
+            <a:srgbClr val="C8382A"/>
+          </a:solidFill>
+          <a:ln>
+            <a:noFill/>
+          </a:ln>
+        </p:spPr>
+        <p:style>
+          <a:lnRef idx="1">
+            <a:schemeClr val="accent1"/>
+          </a:lnRef>
+          <a:fillRef idx="3">
+            <a:schemeClr val="accent1"/>
+          </a:fillRef>
+          <a:effectRef idx="2">
+            <a:schemeClr val="accent1"/>
+          </a:effectRef>
+          <a:fontRef idx="minor">
+            <a:schemeClr val="lt1"/>
+          </a:fontRef>
+        </p:style>
+        <p:txBody>
+          <a:bodyPr rtlCol="0" anchor="ctr"/>
+          <a:lstStyle/>
+          <a:p>
+            <a:pPr algn="ctr"/>
+            <a:endParaRPr/>
+          </a:p>
+        </p:txBody>
+      </p:sp>
+      <p:sp>
+        <p:nvSpPr>
+          <p:cNvPr id="3" name="TextBox 2"/>
+          <p:cNvSpPr txBox="1"/>
+          <p:nvPr/>
+        </p:nvSpPr>
+        <p:spPr>
+          <a:xfrm>
+            <a:off x="365760" y="164592"/>
+            <a:ext cx="8229600" cy="548640"/>
+          </a:xfrm>
+          <a:prstGeom prst="rect">
+            <a:avLst/>
+          </a:prstGeom>
+          <a:noFill/>
+        </p:spPr>
+        <p:txBody>
+          <a:bodyPr wrap="square">
+            <a:spAutoFit/>
+          </a:bodyPr>
+          <a:lstStyle/>
+          <a:p>
+            <a:pPr algn="l"/>
+            <a:r>
+              <a:rPr sz="2200" b="1">
+                <a:solidFill>
+                  <a:srgbClr val="1A1410"/>
+                </a:solidFill>
+              </a:rPr>
+              <a:t>Sazonalidade e Distribuição de Alertas</a:t>
+            </a:r>
+          </a:p>
+        </p:txBody>
+      </p:sp>
+      <p:sp>
+        <p:nvSpPr>
+          <p:cNvPr id="4" name="TextBox 3"/>
+          <p:cNvSpPr txBox="1"/>
+          <p:nvPr/>
+        </p:nvSpPr>
+        <p:spPr>
+          <a:xfrm>
+            <a:off x="365760" y="685800"/>
+            <a:ext cx="8229600" cy="365760"/>
+          </a:xfrm>
+          <a:prstGeom prst="rect">
+            <a:avLst/>
+          </a:prstGeom>
+          <a:noFill/>
+        </p:spPr>
+        <p:txBody>
+          <a:bodyPr wrap="square">
+            <a:spAutoFit/>
+          </a:bodyPr>
+          <a:lstStyle/>
+          <a:p>
+            <a:pPr algn="l"/>
+            <a:r>
+              <a:rPr sz="1200" b="0">
+                <a:solidFill>
+                  <a:srgbClr val="6B5E58"/>
+                </a:solidFill>
+              </a:rPr>
+              <a:t>Padrão mensal e semanas por nível epidemiológico</a:t>
+            </a:r>
+          </a:p>
+        </p:txBody>
+      </p:sp>
+      <p:sp>
+        <p:nvSpPr>
+          <p:cNvPr id="5" name="TextBox 4"/>
+          <p:cNvSpPr txBox="1"/>
+          <p:nvPr/>
+        </p:nvSpPr>
+        <p:spPr>
+          <a:xfrm>
+            <a:off x="365760" y="1188720"/>
+            <a:ext cx="4114800" cy="274320"/>
+          </a:xfrm>
+          <a:prstGeom prst="rect">
+            <a:avLst/>
+          </a:prstGeom>
+          <a:noFill/>
+        </p:spPr>
+        <p:txBody>
+          <a:bodyPr wrap="square">
+            <a:spAutoFit/>
+          </a:bodyPr>
+          <a:lstStyle/>
+          <a:p>
+            <a:pPr algn="l"/>
+            <a:r>
+              <a:rPr sz="1100" b="1">
+                <a:solidFill>
+                  <a:srgbClr val="6B5E58"/>
+                </a:solidFill>
+              </a:rPr>
+              <a:t>Média de casos por mês</a:t>
+            </a:r>
+          </a:p>
+        </p:txBody>
+      </p:sp>
+      <p:sp>
+        <p:nvSpPr>
+          <p:cNvPr id="6" name="TextBox 5"/>
+          <p:cNvSpPr txBox="1"/>
+          <p:nvPr/>
+        </p:nvSpPr>
+        <p:spPr>
+          <a:xfrm>
+            <a:off x="4663440" y="1188720"/>
+            <a:ext cx="4114800" cy="274320"/>
+          </a:xfrm>
+          <a:prstGeom prst="rect">
+            <a:avLst/>
+          </a:prstGeom>
+          <a:noFill/>
+        </p:spPr>
+        <p:txBody>
+          <a:bodyPr wrap="square">
+            <a:spAutoFit/>
+          </a:bodyPr>
+          <a:lstStyle/>
+          <a:p>
+            <a:pPr algn="l"/>
+            <a:r>
+              <a:rPr sz="1100" b="1">
+                <a:solidFill>
+                  <a:srgbClr val="6B5E58"/>
+                </a:solidFill>
+              </a:rPr>
+              <a:t>Níveis de alerta (1=verde … 4=vermelho)</a:t>
             </a:r>
           </a:p>
         </p:txBody>
       </p:sp>
       <p:pic>
         <p:nvPicPr>
-          <p:cNvPr id="3" name="Picture 2" descr="previsao_xgboost.png"/>
+          <p:cNvPr id="7" name="Picture 6" descr="niveis_alerta.png"/>
           <p:cNvPicPr>
             <a:picLocks noChangeAspect="1"/>
           </p:cNvPicPr>
@@ -3357,8 +4932,1498 @@
         </p:blipFill>
         <p:spPr>
           <a:xfrm>
-            <a:off x="914400" y="1828800"/>
-            <a:ext cx="5486400" cy="1567543"/>
+            <a:off x="4572000" y="1463040"/>
+            <a:ext cx="4297680" cy="3223260"/>
+          </a:xfrm>
+          <a:prstGeom prst="rect">
+            <a:avLst/>
+          </a:prstGeom>
+        </p:spPr>
+      </p:pic>
+    </p:spTree>
+  </p:cSld>
+  <p:clrMapOvr>
+    <a:masterClrMapping/>
+  </p:clrMapOvr>
+</p:sld>
+</file>
+
+<file path=ppt/slides/slide5.xml><?xml version="1.0" encoding="utf-8"?>
+<p:sld xmlns:a="http://schemas.openxmlformats.org/drawingml/2006/main" xmlns:r="http://schemas.openxmlformats.org/officeDocument/2006/relationships" xmlns:p="http://schemas.openxmlformats.org/presentationml/2006/main">
+  <p:cSld>
+    <p:bg>
+      <p:bgPr>
+        <a:solidFill>
+          <a:srgbClr val="C8382A"/>
+        </a:solidFill>
+        <a:effectLst/>
+      </p:bgPr>
+    </p:bg>
+    <p:spTree>
+      <p:nvGrpSpPr>
+        <p:cNvPr id="1" name=""/>
+        <p:cNvGrpSpPr/>
+        <p:nvPr/>
+      </p:nvGrpSpPr>
+      <p:grpSpPr>
+        <a:xfrm>
+          <a:off x="0" y="0"/>
+          <a:ext cx="0" cy="0"/>
+          <a:chOff x="0" y="0"/>
+          <a:chExt cx="0" cy="0"/>
+        </a:xfrm>
+      </p:grpSpPr>
+      <p:sp>
+        <p:nvSpPr>
+          <p:cNvPr id="2" name="Rectangle 1"/>
+          <p:cNvSpPr/>
+          <p:nvPr/>
+        </p:nvSpPr>
+        <p:spPr>
+          <a:xfrm>
+            <a:off x="0" y="0"/>
+            <a:ext cx="109728" cy="6858000"/>
+          </a:xfrm>
+          <a:prstGeom prst="rect">
+            <a:avLst/>
+          </a:prstGeom>
+          <a:solidFill>
+            <a:srgbClr val="AA281C"/>
+          </a:solidFill>
+          <a:ln>
+            <a:noFill/>
+          </a:ln>
+        </p:spPr>
+        <p:style>
+          <a:lnRef idx="1">
+            <a:schemeClr val="accent1"/>
+          </a:lnRef>
+          <a:fillRef idx="3">
+            <a:schemeClr val="accent1"/>
+          </a:fillRef>
+          <a:effectRef idx="2">
+            <a:schemeClr val="accent1"/>
+          </a:effectRef>
+          <a:fontRef idx="minor">
+            <a:schemeClr val="lt1"/>
+          </a:fontRef>
+        </p:style>
+        <p:txBody>
+          <a:bodyPr rtlCol="0" anchor="ctr"/>
+          <a:lstStyle/>
+          <a:p>
+            <a:pPr algn="ctr"/>
+            <a:endParaRPr/>
+          </a:p>
+        </p:txBody>
+      </p:sp>
+      <p:sp>
+        <p:nvSpPr>
+          <p:cNvPr id="3" name="TextBox 2"/>
+          <p:cNvSpPr txBox="1"/>
+          <p:nvPr/>
+        </p:nvSpPr>
+        <p:spPr>
+          <a:xfrm>
+            <a:off x="457200" y="2286000"/>
+            <a:ext cx="8229600" cy="1097280"/>
+          </a:xfrm>
+          <a:prstGeom prst="rect">
+            <a:avLst/>
+          </a:prstGeom>
+          <a:noFill/>
+        </p:spPr>
+        <p:txBody>
+          <a:bodyPr wrap="square">
+            <a:spAutoFit/>
+          </a:bodyPr>
+          <a:lstStyle/>
+          <a:p>
+            <a:pPr algn="ctr"/>
+            <a:r>
+              <a:rPr sz="3600" b="1">
+                <a:solidFill>
+                  <a:srgbClr val="FFFFFF"/>
+                </a:solidFill>
+              </a:rPr>
+              <a:t>02. Machine Learning</a:t>
+            </a:r>
+          </a:p>
+        </p:txBody>
+      </p:sp>
+      <p:sp>
+        <p:nvSpPr>
+          <p:cNvPr id="4" name="TextBox 3"/>
+          <p:cNvSpPr txBox="1"/>
+          <p:nvPr/>
+        </p:nvSpPr>
+        <p:spPr>
+          <a:xfrm>
+            <a:off x="457200" y="3291840"/>
+            <a:ext cx="8229600" cy="548640"/>
+          </a:xfrm>
+          <a:prstGeom prst="rect">
+            <a:avLst/>
+          </a:prstGeom>
+          <a:noFill/>
+        </p:spPr>
+        <p:txBody>
+          <a:bodyPr wrap="square">
+            <a:spAutoFit/>
+          </a:bodyPr>
+          <a:lstStyle/>
+          <a:p>
+            <a:pPr algn="ctr"/>
+            <a:r>
+              <a:rPr sz="1400" b="0">
+                <a:solidFill>
+                  <a:srgbClr val="FFCCCC"/>
+                </a:solidFill>
+              </a:rPr>
+              <a:t>Regressão Linear · Random Forest · XGBoost + Cross-validation</a:t>
+            </a:r>
+          </a:p>
+        </p:txBody>
+      </p:sp>
+    </p:spTree>
+  </p:cSld>
+  <p:clrMapOvr>
+    <a:masterClrMapping/>
+  </p:clrMapOvr>
+</p:sld>
+</file>
+
+<file path=ppt/slides/slide6.xml><?xml version="1.0" encoding="utf-8"?>
+<p:sld xmlns:a="http://schemas.openxmlformats.org/drawingml/2006/main" xmlns:r="http://schemas.openxmlformats.org/officeDocument/2006/relationships" xmlns:p="http://schemas.openxmlformats.org/presentationml/2006/main">
+  <p:cSld>
+    <p:bg>
+      <p:bgPr>
+        <a:solidFill>
+          <a:srgbClr val="FAF7F4"/>
+        </a:solidFill>
+        <a:effectLst/>
+      </p:bgPr>
+    </p:bg>
+    <p:spTree>
+      <p:nvGrpSpPr>
+        <p:cNvPr id="1" name=""/>
+        <p:cNvGrpSpPr/>
+        <p:nvPr/>
+      </p:nvGrpSpPr>
+      <p:grpSpPr>
+        <a:xfrm>
+          <a:off x="0" y="0"/>
+          <a:ext cx="0" cy="0"/>
+          <a:chOff x="0" y="0"/>
+          <a:chExt cx="0" cy="0"/>
+        </a:xfrm>
+      </p:grpSpPr>
+      <p:sp>
+        <p:nvSpPr>
+          <p:cNvPr id="2" name="Rectangle 1"/>
+          <p:cNvSpPr/>
+          <p:nvPr/>
+        </p:nvSpPr>
+        <p:spPr>
+          <a:xfrm>
+            <a:off x="0" y="0"/>
+            <a:ext cx="9144000" cy="73152"/>
+          </a:xfrm>
+          <a:prstGeom prst="rect">
+            <a:avLst/>
+          </a:prstGeom>
+          <a:solidFill>
+            <a:srgbClr val="C8382A"/>
+          </a:solidFill>
+          <a:ln>
+            <a:noFill/>
+          </a:ln>
+        </p:spPr>
+        <p:style>
+          <a:lnRef idx="1">
+            <a:schemeClr val="accent1"/>
+          </a:lnRef>
+          <a:fillRef idx="3">
+            <a:schemeClr val="accent1"/>
+          </a:fillRef>
+          <a:effectRef idx="2">
+            <a:schemeClr val="accent1"/>
+          </a:effectRef>
+          <a:fontRef idx="minor">
+            <a:schemeClr val="lt1"/>
+          </a:fontRef>
+        </p:style>
+        <p:txBody>
+          <a:bodyPr rtlCol="0" anchor="ctr"/>
+          <a:lstStyle/>
+          <a:p>
+            <a:pPr algn="ctr"/>
+            <a:endParaRPr/>
+          </a:p>
+        </p:txBody>
+      </p:sp>
+      <p:sp>
+        <p:nvSpPr>
+          <p:cNvPr id="3" name="TextBox 2"/>
+          <p:cNvSpPr txBox="1"/>
+          <p:nvPr/>
+        </p:nvSpPr>
+        <p:spPr>
+          <a:xfrm>
+            <a:off x="365760" y="164592"/>
+            <a:ext cx="8229600" cy="548640"/>
+          </a:xfrm>
+          <a:prstGeom prst="rect">
+            <a:avLst/>
+          </a:prstGeom>
+          <a:noFill/>
+        </p:spPr>
+        <p:txBody>
+          <a:bodyPr wrap="square">
+            <a:spAutoFit/>
+          </a:bodyPr>
+          <a:lstStyle/>
+          <a:p>
+            <a:pPr algn="l"/>
+            <a:r>
+              <a:rPr sz="2200" b="1">
+                <a:solidFill>
+                  <a:srgbClr val="1A1410"/>
+                </a:solidFill>
+              </a:rPr>
+              <a:t>Correlação: Temperatura, Umidade e Casos</a:t>
+            </a:r>
+          </a:p>
+        </p:txBody>
+      </p:sp>
+      <p:sp>
+        <p:nvSpPr>
+          <p:cNvPr id="4" name="TextBox 3"/>
+          <p:cNvSpPr txBox="1"/>
+          <p:nvPr/>
+        </p:nvSpPr>
+        <p:spPr>
+          <a:xfrm>
+            <a:off x="365760" y="685800"/>
+            <a:ext cx="8229600" cy="365760"/>
+          </a:xfrm>
+          <a:prstGeom prst="rect">
+            <a:avLst/>
+          </a:prstGeom>
+          <a:noFill/>
+        </p:spPr>
+        <p:txBody>
+          <a:bodyPr wrap="square">
+            <a:spAutoFit/>
+          </a:bodyPr>
+          <a:lstStyle/>
+          <a:p>
+            <a:pPr algn="l"/>
+            <a:r>
+              <a:rPr sz="1200" b="0">
+                <a:solidFill>
+                  <a:srgbClr val="6B5E58"/>
+                </a:solidFill>
+              </a:rPr>
+              <a:t>Dispersão semanal — pares de variáveis climáticas vs casos</a:t>
+            </a:r>
+          </a:p>
+        </p:txBody>
+      </p:sp>
+      <p:pic>
+        <p:nvPicPr>
+          <p:cNvPr id="5" name="Picture 4" descr="correlacao.png"/>
+          <p:cNvPicPr>
+            <a:picLocks noChangeAspect="1"/>
+          </p:cNvPicPr>
+          <p:nvPr/>
+        </p:nvPicPr>
+        <p:blipFill>
+          <a:blip r:embed="rId2"/>
+          <a:stretch>
+            <a:fillRect/>
+          </a:stretch>
+        </p:blipFill>
+        <p:spPr>
+          <a:xfrm>
+            <a:off x="457200" y="1463040"/>
+            <a:ext cx="8229600" cy="8229600"/>
+          </a:xfrm>
+          <a:prstGeom prst="rect">
+            <a:avLst/>
+          </a:prstGeom>
+        </p:spPr>
+      </p:pic>
+    </p:spTree>
+  </p:cSld>
+  <p:clrMapOvr>
+    <a:masterClrMapping/>
+  </p:clrMapOvr>
+</p:sld>
+</file>
+
+<file path=ppt/slides/slide7.xml><?xml version="1.0" encoding="utf-8"?>
+<p:sld xmlns:a="http://schemas.openxmlformats.org/drawingml/2006/main" xmlns:r="http://schemas.openxmlformats.org/officeDocument/2006/relationships" xmlns:p="http://schemas.openxmlformats.org/presentationml/2006/main">
+  <p:cSld>
+    <p:bg>
+      <p:bgPr>
+        <a:solidFill>
+          <a:srgbClr val="FAF7F4"/>
+        </a:solidFill>
+        <a:effectLst/>
+      </p:bgPr>
+    </p:bg>
+    <p:spTree>
+      <p:nvGrpSpPr>
+        <p:cNvPr id="1" name=""/>
+        <p:cNvGrpSpPr/>
+        <p:nvPr/>
+      </p:nvGrpSpPr>
+      <p:grpSpPr>
+        <a:xfrm>
+          <a:off x="0" y="0"/>
+          <a:ext cx="0" cy="0"/>
+          <a:chOff x="0" y="0"/>
+          <a:chExt cx="0" cy="0"/>
+        </a:xfrm>
+      </p:grpSpPr>
+      <p:sp>
+        <p:nvSpPr>
+          <p:cNvPr id="2" name="Rectangle 1"/>
+          <p:cNvSpPr/>
+          <p:nvPr/>
+        </p:nvSpPr>
+        <p:spPr>
+          <a:xfrm>
+            <a:off x="0" y="0"/>
+            <a:ext cx="9144000" cy="73152"/>
+          </a:xfrm>
+          <a:prstGeom prst="rect">
+            <a:avLst/>
+          </a:prstGeom>
+          <a:solidFill>
+            <a:srgbClr val="C8382A"/>
+          </a:solidFill>
+          <a:ln>
+            <a:noFill/>
+          </a:ln>
+        </p:spPr>
+        <p:style>
+          <a:lnRef idx="1">
+            <a:schemeClr val="accent1"/>
+          </a:lnRef>
+          <a:fillRef idx="3">
+            <a:schemeClr val="accent1"/>
+          </a:fillRef>
+          <a:effectRef idx="2">
+            <a:schemeClr val="accent1"/>
+          </a:effectRef>
+          <a:fontRef idx="minor">
+            <a:schemeClr val="lt1"/>
+          </a:fontRef>
+        </p:style>
+        <p:txBody>
+          <a:bodyPr rtlCol="0" anchor="ctr"/>
+          <a:lstStyle/>
+          <a:p>
+            <a:pPr algn="ctr"/>
+            <a:endParaRPr/>
+          </a:p>
+        </p:txBody>
+      </p:sp>
+      <p:sp>
+        <p:nvSpPr>
+          <p:cNvPr id="3" name="TextBox 2"/>
+          <p:cNvSpPr txBox="1"/>
+          <p:nvPr/>
+        </p:nvSpPr>
+        <p:spPr>
+          <a:xfrm>
+            <a:off x="365760" y="164592"/>
+            <a:ext cx="8229600" cy="548640"/>
+          </a:xfrm>
+          <a:prstGeom prst="rect">
+            <a:avLst/>
+          </a:prstGeom>
+          <a:noFill/>
+        </p:spPr>
+        <p:txBody>
+          <a:bodyPr wrap="square">
+            <a:spAutoFit/>
+          </a:bodyPr>
+          <a:lstStyle/>
+          <a:p>
+            <a:pPr algn="l"/>
+            <a:r>
+              <a:rPr sz="2200" b="1">
+                <a:solidFill>
+                  <a:srgbClr val="1A1410"/>
+                </a:solidFill>
+              </a:rPr>
+              <a:t>Resultados dos Modelos ML</a:t>
+            </a:r>
+          </a:p>
+        </p:txBody>
+      </p:sp>
+      <p:sp>
+        <p:nvSpPr>
+          <p:cNvPr id="4" name="TextBox 3"/>
+          <p:cNvSpPr txBox="1"/>
+          <p:nvPr/>
+        </p:nvSpPr>
+        <p:spPr>
+          <a:xfrm>
+            <a:off x="365760" y="685800"/>
+            <a:ext cx="8229600" cy="365760"/>
+          </a:xfrm>
+          <a:prstGeom prst="rect">
+            <a:avLst/>
+          </a:prstGeom>
+          <a:noFill/>
+        </p:spPr>
+        <p:txBody>
+          <a:bodyPr wrap="square">
+            <a:spAutoFit/>
+          </a:bodyPr>
+          <a:lstStyle/>
+          <a:p>
+            <a:pPr algn="l"/>
+            <a:r>
+              <a:rPr sz="1200" b="0">
+                <a:solidFill>
+                  <a:srgbClr val="6B5E58"/>
+                </a:solidFill>
+              </a:rPr>
+              <a:t>Split temporal 80/20 · Validação cruzada 5-fold</a:t>
+            </a:r>
+          </a:p>
+        </p:txBody>
+      </p:sp>
+      <p:graphicFrame>
+        <p:nvGraphicFramePr>
+          <p:cNvPr id="5" name="Table 4"/>
+          <p:cNvGraphicFramePr>
+            <a:graphicFrameLocks noGrp="1"/>
+          </p:cNvGraphicFramePr>
+          <p:nvPr/>
+        </p:nvGraphicFramePr>
+        <p:xfrm>
+          <a:off x="274320" y="1280160"/>
+          <a:ext cx="8595360" cy="2560320"/>
+        </p:xfrm>
+        <a:graphic>
+          <a:graphicData uri="http://schemas.openxmlformats.org/drawingml/2006/table">
+            <a:tbl>
+              <a:tblPr firstRow="1" bandRow="1">
+                <a:tableStyleId>{5C22544A-7EE6-4342-B048-85BDC9FD1C3A}</a:tableStyleId>
+              </a:tblPr>
+              <a:tblGrid>
+                <a:gridCol w="1719072">
+                  <a:extLst>
+                    <a:ext uri="{9D8B030D-6E8A-4147-A177-3AD203B41FA5}">
+                      <a16:colId xmlns:a16="http://schemas.microsoft.com/office/drawing/2014/main" val="20000"/>
+                    </a:ext>
+                  </a:extLst>
+                </a:gridCol>
+                <a:gridCol w="1719072">
+                  <a:extLst>
+                    <a:ext uri="{9D8B030D-6E8A-4147-A177-3AD203B41FA5}">
+                      <a16:colId xmlns:a16="http://schemas.microsoft.com/office/drawing/2014/main" val="20001"/>
+                    </a:ext>
+                  </a:extLst>
+                </a:gridCol>
+                <a:gridCol w="1719072">
+                  <a:extLst>
+                    <a:ext uri="{9D8B030D-6E8A-4147-A177-3AD203B41FA5}">
+                      <a16:colId xmlns:a16="http://schemas.microsoft.com/office/drawing/2014/main" val="20002"/>
+                    </a:ext>
+                  </a:extLst>
+                </a:gridCol>
+                <a:gridCol w="1719072">
+                  <a:extLst>
+                    <a:ext uri="{9D8B030D-6E8A-4147-A177-3AD203B41FA5}">
+                      <a16:colId xmlns:a16="http://schemas.microsoft.com/office/drawing/2014/main" val="20003"/>
+                    </a:ext>
+                  </a:extLst>
+                </a:gridCol>
+                <a:gridCol w="1719072">
+                  <a:extLst>
+                    <a:ext uri="{9D8B030D-6E8A-4147-A177-3AD203B41FA5}">
+                      <a16:colId xmlns:a16="http://schemas.microsoft.com/office/drawing/2014/main" val="20004"/>
+                    </a:ext>
+                  </a:extLst>
+                </a:gridCol>
+              </a:tblGrid>
+              <a:tr h="640080">
+                <a:tc>
+                  <a:txBody>
+                    <a:bodyPr/>
+                    <a:lstStyle/>
+                    <a:p>
+                      <a:pPr algn="ctr"/>
+                      <a:r>
+                        <a:rPr sz="1300" b="1">
+                          <a:solidFill>
+                            <a:srgbClr val="FFFFFF"/>
+                          </a:solidFill>
+                        </a:rPr>
+                        <a:t>Modelo</a:t>
+                      </a:r>
+                    </a:p>
+                  </a:txBody>
+                  <a:tcPr>
+                    <a:solidFill>
+                      <a:srgbClr val="C8382A"/>
+                    </a:solidFill>
+                  </a:tcPr>
+                </a:tc>
+                <a:tc>
+                  <a:txBody>
+                    <a:bodyPr/>
+                    <a:lstStyle/>
+                    <a:p>
+                      <a:pPr algn="ctr"/>
+                      <a:r>
+                        <a:rPr sz="1300" b="1">
+                          <a:solidFill>
+                            <a:srgbClr val="FFFFFF"/>
+                          </a:solidFill>
+                        </a:rPr>
+                        <a:t>MAE</a:t>
+                      </a:r>
+                    </a:p>
+                  </a:txBody>
+                  <a:tcPr>
+                    <a:solidFill>
+                      <a:srgbClr val="C8382A"/>
+                    </a:solidFill>
+                  </a:tcPr>
+                </a:tc>
+                <a:tc>
+                  <a:txBody>
+                    <a:bodyPr/>
+                    <a:lstStyle/>
+                    <a:p>
+                      <a:pPr algn="ctr"/>
+                      <a:r>
+                        <a:rPr sz="1300" b="1">
+                          <a:solidFill>
+                            <a:srgbClr val="FFFFFF"/>
+                          </a:solidFill>
+                        </a:rPr>
+                        <a:t>RMSE</a:t>
+                      </a:r>
+                    </a:p>
+                  </a:txBody>
+                  <a:tcPr>
+                    <a:solidFill>
+                      <a:srgbClr val="C8382A"/>
+                    </a:solidFill>
+                  </a:tcPr>
+                </a:tc>
+                <a:tc>
+                  <a:txBody>
+                    <a:bodyPr/>
+                    <a:lstStyle/>
+                    <a:p>
+                      <a:pPr algn="ctr"/>
+                      <a:r>
+                        <a:rPr sz="1300" b="1">
+                          <a:solidFill>
+                            <a:srgbClr val="FFFFFF"/>
+                          </a:solidFill>
+                        </a:rPr>
+                        <a:t>R²</a:t>
+                      </a:r>
+                    </a:p>
+                  </a:txBody>
+                  <a:tcPr>
+                    <a:solidFill>
+                      <a:srgbClr val="C8382A"/>
+                    </a:solidFill>
+                  </a:tcPr>
+                </a:tc>
+                <a:tc>
+                  <a:txBody>
+                    <a:bodyPr/>
+                    <a:lstStyle/>
+                    <a:p>
+                      <a:pPr algn="ctr"/>
+                      <a:r>
+                        <a:rPr sz="1300" b="1">
+                          <a:solidFill>
+                            <a:srgbClr val="FFFFFF"/>
+                          </a:solidFill>
+                        </a:rPr>
+                        <a:t>CV R² médio</a:t>
+                      </a:r>
+                    </a:p>
+                  </a:txBody>
+                  <a:tcPr>
+                    <a:solidFill>
+                      <a:srgbClr val="C8382A"/>
+                    </a:solidFill>
+                  </a:tcPr>
+                </a:tc>
+                <a:extLst>
+                  <a:ext uri="{0D108BD9-81ED-4DB2-BD59-A6C34878D82A}">
+                    <a16:rowId xmlns:a16="http://schemas.microsoft.com/office/drawing/2014/main" val="10000"/>
+                  </a:ext>
+                </a:extLst>
+              </a:tr>
+              <a:tr h="640080">
+                <a:tc>
+                  <a:txBody>
+                    <a:bodyPr/>
+                    <a:lstStyle/>
+                    <a:p>
+                      <a:pPr algn="l"/>
+                      <a:r>
+                        <a:rPr sz="1300" b="0">
+                          <a:solidFill>
+                            <a:srgbClr val="1A1410"/>
+                          </a:solidFill>
+                        </a:rPr>
+                        <a:t>Regressão Linear</a:t>
+                      </a:r>
+                    </a:p>
+                  </a:txBody>
+                  <a:tcPr>
+                    <a:solidFill>
+                      <a:srgbClr val="FFFFFF"/>
+                    </a:solidFill>
+                  </a:tcPr>
+                </a:tc>
+                <a:tc>
+                  <a:txBody>
+                    <a:bodyPr/>
+                    <a:lstStyle/>
+                    <a:p>
+                      <a:pPr algn="ctr"/>
+                      <a:r>
+                        <a:rPr sz="1300" b="0">
+                          <a:solidFill>
+                            <a:srgbClr val="1A1410"/>
+                          </a:solidFill>
+                        </a:rPr>
+                        <a:t>21.9</a:t>
+                      </a:r>
+                    </a:p>
+                  </a:txBody>
+                  <a:tcPr>
+                    <a:solidFill>
+                      <a:srgbClr val="FFFFFF"/>
+                    </a:solidFill>
+                  </a:tcPr>
+                </a:tc>
+                <a:tc>
+                  <a:txBody>
+                    <a:bodyPr/>
+                    <a:lstStyle/>
+                    <a:p>
+                      <a:pPr algn="ctr"/>
+                      <a:r>
+                        <a:rPr sz="1300" b="0">
+                          <a:solidFill>
+                            <a:srgbClr val="1A1410"/>
+                          </a:solidFill>
+                        </a:rPr>
+                        <a:t>30.6</a:t>
+                      </a:r>
+                    </a:p>
+                  </a:txBody>
+                  <a:tcPr>
+                    <a:solidFill>
+                      <a:srgbClr val="FFFFFF"/>
+                    </a:solidFill>
+                  </a:tcPr>
+                </a:tc>
+                <a:tc>
+                  <a:txBody>
+                    <a:bodyPr/>
+                    <a:lstStyle/>
+                    <a:p>
+                      <a:pPr algn="ctr"/>
+                      <a:r>
+                        <a:rPr sz="1300" b="0">
+                          <a:solidFill>
+                            <a:srgbClr val="1A1410"/>
+                          </a:solidFill>
+                        </a:rPr>
+                        <a:t>0.976</a:t>
+                      </a:r>
+                    </a:p>
+                  </a:txBody>
+                  <a:tcPr>
+                    <a:solidFill>
+                      <a:srgbClr val="FFFFFF"/>
+                    </a:solidFill>
+                  </a:tcPr>
+                </a:tc>
+                <a:tc>
+                  <a:txBody>
+                    <a:bodyPr/>
+                    <a:lstStyle/>
+                    <a:p>
+                      <a:pPr algn="ctr"/>
+                      <a:r>
+                        <a:rPr sz="1300" b="0">
+                          <a:solidFill>
+                            <a:srgbClr val="1A1410"/>
+                          </a:solidFill>
+                        </a:rPr>
+                        <a:t>0.891</a:t>
+                      </a:r>
+                    </a:p>
+                  </a:txBody>
+                  <a:tcPr>
+                    <a:solidFill>
+                      <a:srgbClr val="FFFFFF"/>
+                    </a:solidFill>
+                  </a:tcPr>
+                </a:tc>
+                <a:extLst>
+                  <a:ext uri="{0D108BD9-81ED-4DB2-BD59-A6C34878D82A}">
+                    <a16:rowId xmlns:a16="http://schemas.microsoft.com/office/drawing/2014/main" val="10001"/>
+                  </a:ext>
+                </a:extLst>
+              </a:tr>
+              <a:tr h="640080">
+                <a:tc>
+                  <a:txBody>
+                    <a:bodyPr/>
+                    <a:lstStyle/>
+                    <a:p>
+                      <a:pPr algn="l"/>
+                      <a:r>
+                        <a:rPr sz="1300" b="0">
+                          <a:solidFill>
+                            <a:srgbClr val="1A1410"/>
+                          </a:solidFill>
+                        </a:rPr>
+                        <a:t>Random Forest</a:t>
+                      </a:r>
+                    </a:p>
+                  </a:txBody>
+                  <a:tcPr>
+                    <a:solidFill>
+                      <a:srgbClr val="FAF7F4"/>
+                    </a:solidFill>
+                  </a:tcPr>
+                </a:tc>
+                <a:tc>
+                  <a:txBody>
+                    <a:bodyPr/>
+                    <a:lstStyle/>
+                    <a:p>
+                      <a:pPr algn="ctr"/>
+                      <a:r>
+                        <a:rPr sz="1300" b="0">
+                          <a:solidFill>
+                            <a:srgbClr val="1A1410"/>
+                          </a:solidFill>
+                        </a:rPr>
+                        <a:t>17.5</a:t>
+                      </a:r>
+                    </a:p>
+                  </a:txBody>
+                  <a:tcPr>
+                    <a:solidFill>
+                      <a:srgbClr val="FAF7F4"/>
+                    </a:solidFill>
+                  </a:tcPr>
+                </a:tc>
+                <a:tc>
+                  <a:txBody>
+                    <a:bodyPr/>
+                    <a:lstStyle/>
+                    <a:p>
+                      <a:pPr algn="ctr"/>
+                      <a:r>
+                        <a:rPr sz="1300" b="0">
+                          <a:solidFill>
+                            <a:srgbClr val="1A1410"/>
+                          </a:solidFill>
+                        </a:rPr>
+                        <a:t>41.0</a:t>
+                      </a:r>
+                    </a:p>
+                  </a:txBody>
+                  <a:tcPr>
+                    <a:solidFill>
+                      <a:srgbClr val="FAF7F4"/>
+                    </a:solidFill>
+                  </a:tcPr>
+                </a:tc>
+                <a:tc>
+                  <a:txBody>
+                    <a:bodyPr/>
+                    <a:lstStyle/>
+                    <a:p>
+                      <a:pPr algn="ctr"/>
+                      <a:r>
+                        <a:rPr sz="1300" b="0">
+                          <a:solidFill>
+                            <a:srgbClr val="1A1410"/>
+                          </a:solidFill>
+                        </a:rPr>
+                        <a:t>0.958</a:t>
+                      </a:r>
+                    </a:p>
+                  </a:txBody>
+                  <a:tcPr>
+                    <a:solidFill>
+                      <a:srgbClr val="FAF7F4"/>
+                    </a:solidFill>
+                  </a:tcPr>
+                </a:tc>
+                <a:tc>
+                  <a:txBody>
+                    <a:bodyPr/>
+                    <a:lstStyle/>
+                    <a:p>
+                      <a:pPr algn="ctr"/>
+                      <a:r>
+                        <a:rPr sz="1300" b="0">
+                          <a:solidFill>
+                            <a:srgbClr val="1A1410"/>
+                          </a:solidFill>
+                        </a:rPr>
+                        <a:t>0.877</a:t>
+                      </a:r>
+                    </a:p>
+                  </a:txBody>
+                  <a:tcPr>
+                    <a:solidFill>
+                      <a:srgbClr val="FAF7F4"/>
+                    </a:solidFill>
+                  </a:tcPr>
+                </a:tc>
+                <a:extLst>
+                  <a:ext uri="{0D108BD9-81ED-4DB2-BD59-A6C34878D82A}">
+                    <a16:rowId xmlns:a16="http://schemas.microsoft.com/office/drawing/2014/main" val="10002"/>
+                  </a:ext>
+                </a:extLst>
+              </a:tr>
+              <a:tr h="640080">
+                <a:tc>
+                  <a:txBody>
+                    <a:bodyPr/>
+                    <a:lstStyle/>
+                    <a:p>
+                      <a:pPr algn="l"/>
+                      <a:r>
+                        <a:rPr sz="1300" b="0">
+                          <a:solidFill>
+                            <a:srgbClr val="1A1410"/>
+                          </a:solidFill>
+                        </a:rPr>
+                        <a:t>XGBoost ★</a:t>
+                      </a:r>
+                    </a:p>
+                  </a:txBody>
+                  <a:tcPr>
+                    <a:solidFill>
+                      <a:srgbClr val="FFF3F2"/>
+                    </a:solidFill>
+                  </a:tcPr>
+                </a:tc>
+                <a:tc>
+                  <a:txBody>
+                    <a:bodyPr/>
+                    <a:lstStyle/>
+                    <a:p>
+                      <a:pPr algn="ctr"/>
+                      <a:r>
+                        <a:rPr sz="1300" b="1">
+                          <a:solidFill>
+                            <a:srgbClr val="C8382A"/>
+                          </a:solidFill>
+                        </a:rPr>
+                        <a:t>14.3</a:t>
+                      </a:r>
+                    </a:p>
+                  </a:txBody>
+                  <a:tcPr>
+                    <a:solidFill>
+                      <a:srgbClr val="FFF3F2"/>
+                    </a:solidFill>
+                  </a:tcPr>
+                </a:tc>
+                <a:tc>
+                  <a:txBody>
+                    <a:bodyPr/>
+                    <a:lstStyle/>
+                    <a:p>
+                      <a:pPr algn="ctr"/>
+                      <a:r>
+                        <a:rPr sz="1300" b="0">
+                          <a:solidFill>
+                            <a:srgbClr val="1A1410"/>
+                          </a:solidFill>
+                        </a:rPr>
+                        <a:t>38.1</a:t>
+                      </a:r>
+                    </a:p>
+                  </a:txBody>
+                  <a:tcPr>
+                    <a:solidFill>
+                      <a:srgbClr val="FFF3F2"/>
+                    </a:solidFill>
+                  </a:tcPr>
+                </a:tc>
+                <a:tc>
+                  <a:txBody>
+                    <a:bodyPr/>
+                    <a:lstStyle/>
+                    <a:p>
+                      <a:pPr algn="ctr"/>
+                      <a:r>
+                        <a:rPr sz="1300" b="0">
+                          <a:solidFill>
+                            <a:srgbClr val="1A1410"/>
+                          </a:solidFill>
+                        </a:rPr>
+                        <a:t>0.964</a:t>
+                      </a:r>
+                    </a:p>
+                  </a:txBody>
+                  <a:tcPr>
+                    <a:solidFill>
+                      <a:srgbClr val="FFF3F2"/>
+                    </a:solidFill>
+                  </a:tcPr>
+                </a:tc>
+                <a:tc>
+                  <a:txBody>
+                    <a:bodyPr/>
+                    <a:lstStyle/>
+                    <a:p>
+                      <a:pPr algn="ctr"/>
+                      <a:r>
+                        <a:rPr sz="1300" b="0">
+                          <a:solidFill>
+                            <a:srgbClr val="1A1410"/>
+                          </a:solidFill>
+                        </a:rPr>
+                        <a:t>0.876</a:t>
+                      </a:r>
+                    </a:p>
+                  </a:txBody>
+                  <a:tcPr>
+                    <a:solidFill>
+                      <a:srgbClr val="FFF3F2"/>
+                    </a:solidFill>
+                  </a:tcPr>
+                </a:tc>
+                <a:extLst>
+                  <a:ext uri="{0D108BD9-81ED-4DB2-BD59-A6C34878D82A}">
+                    <a16:rowId xmlns:a16="http://schemas.microsoft.com/office/drawing/2014/main" val="10003"/>
+                  </a:ext>
+                </a:extLst>
+              </a:tr>
+            </a:tbl>
+          </a:graphicData>
+        </a:graphic>
+      </p:graphicFrame>
+      <p:sp>
+        <p:nvSpPr>
+          <p:cNvPr id="6" name="Rectangle 5"/>
+          <p:cNvSpPr/>
+          <p:nvPr/>
+        </p:nvSpPr>
+        <p:spPr>
+          <a:xfrm>
+            <a:off x="274320" y="4023360"/>
+            <a:ext cx="8595360" cy="54864"/>
+          </a:xfrm>
+          <a:prstGeom prst="rect">
+            <a:avLst/>
+          </a:prstGeom>
+          <a:solidFill>
+            <a:srgbClr val="C8382A"/>
+          </a:solidFill>
+          <a:ln>
+            <a:noFill/>
+          </a:ln>
+        </p:spPr>
+        <p:style>
+          <a:lnRef idx="1">
+            <a:schemeClr val="accent1"/>
+          </a:lnRef>
+          <a:fillRef idx="3">
+            <a:schemeClr val="accent1"/>
+          </a:fillRef>
+          <a:effectRef idx="2">
+            <a:schemeClr val="accent1"/>
+          </a:effectRef>
+          <a:fontRef idx="minor">
+            <a:schemeClr val="lt1"/>
+          </a:fontRef>
+        </p:style>
+        <p:txBody>
+          <a:bodyPr rtlCol="0" anchor="ctr"/>
+          <a:lstStyle/>
+          <a:p>
+            <a:pPr algn="ctr"/>
+            <a:endParaRPr/>
+          </a:p>
+        </p:txBody>
+      </p:sp>
+      <p:sp>
+        <p:nvSpPr>
+          <p:cNvPr id="7" name="Rectangle 6"/>
+          <p:cNvSpPr/>
+          <p:nvPr/>
+        </p:nvSpPr>
+        <p:spPr>
+          <a:xfrm>
+            <a:off x="274320" y="4160520"/>
+            <a:ext cx="8595360" cy="1097280"/>
+          </a:xfrm>
+          <a:prstGeom prst="rect">
+            <a:avLst/>
+          </a:prstGeom>
+          <a:solidFill>
+            <a:srgbClr val="FFFFFF"/>
+          </a:solidFill>
+          <a:ln>
+            <a:noFill/>
+          </a:ln>
+        </p:spPr>
+        <p:style>
+          <a:lnRef idx="1">
+            <a:schemeClr val="accent1"/>
+          </a:lnRef>
+          <a:fillRef idx="3">
+            <a:schemeClr val="accent1"/>
+          </a:fillRef>
+          <a:effectRef idx="2">
+            <a:schemeClr val="accent1"/>
+          </a:effectRef>
+          <a:fontRef idx="minor">
+            <a:schemeClr val="lt1"/>
+          </a:fontRef>
+        </p:style>
+        <p:txBody>
+          <a:bodyPr rtlCol="0" anchor="ctr"/>
+          <a:lstStyle/>
+          <a:p>
+            <a:pPr algn="ctr"/>
+            <a:endParaRPr/>
+          </a:p>
+        </p:txBody>
+      </p:sp>
+      <p:sp>
+        <p:nvSpPr>
+          <p:cNvPr id="8" name="Rectangle 7"/>
+          <p:cNvSpPr/>
+          <p:nvPr/>
+        </p:nvSpPr>
+        <p:spPr>
+          <a:xfrm>
+            <a:off x="274320" y="4160520"/>
+            <a:ext cx="64008" cy="1097280"/>
+          </a:xfrm>
+          <a:prstGeom prst="rect">
+            <a:avLst/>
+          </a:prstGeom>
+          <a:solidFill>
+            <a:srgbClr val="C8382A"/>
+          </a:solidFill>
+          <a:ln>
+            <a:noFill/>
+          </a:ln>
+        </p:spPr>
+        <p:style>
+          <a:lnRef idx="1">
+            <a:schemeClr val="accent1"/>
+          </a:lnRef>
+          <a:fillRef idx="3">
+            <a:schemeClr val="accent1"/>
+          </a:fillRef>
+          <a:effectRef idx="2">
+            <a:schemeClr val="accent1"/>
+          </a:effectRef>
+          <a:fontRef idx="minor">
+            <a:schemeClr val="lt1"/>
+          </a:fontRef>
+        </p:style>
+        <p:txBody>
+          <a:bodyPr rtlCol="0" anchor="ctr"/>
+          <a:lstStyle/>
+          <a:p>
+            <a:pPr algn="ctr"/>
+            <a:endParaRPr/>
+          </a:p>
+        </p:txBody>
+      </p:sp>
+      <p:sp>
+        <p:nvSpPr>
+          <p:cNvPr id="9" name="TextBox 8"/>
+          <p:cNvSpPr txBox="1"/>
+          <p:nvPr/>
+        </p:nvSpPr>
+        <p:spPr>
+          <a:xfrm>
+            <a:off x="457200" y="4251960"/>
+            <a:ext cx="8229600" cy="914400"/>
+          </a:xfrm>
+          <a:prstGeom prst="rect">
+            <a:avLst/>
+          </a:prstGeom>
+          <a:noFill/>
+        </p:spPr>
+        <p:txBody>
+          <a:bodyPr wrap="square">
+            <a:spAutoFit/>
+          </a:bodyPr>
+          <a:lstStyle/>
+          <a:p>
+            <a:pPr algn="l"/>
+            <a:r>
+              <a:rPr sz="1200" b="0">
+                <a:solidFill>
+                  <a:srgbClr val="6B5E58"/>
+                </a:solidFill>
+              </a:rPr>
+              <a:t>💡  XGBoost erra em média apenas 14,3 casos/semana. Os lag features (casos anteriores) respondem por mais de 70% da importância do modelo, confirmando forte autocorrelação temporal.</a:t>
+            </a:r>
+          </a:p>
+        </p:txBody>
+      </p:sp>
+    </p:spTree>
+  </p:cSld>
+  <p:clrMapOvr>
+    <a:masterClrMapping/>
+  </p:clrMapOvr>
+</p:sld>
+</file>
+
+<file path=ppt/slides/slide8.xml><?xml version="1.0" encoding="utf-8"?>
+<p:sld xmlns:a="http://schemas.openxmlformats.org/drawingml/2006/main" xmlns:r="http://schemas.openxmlformats.org/officeDocument/2006/relationships" xmlns:p="http://schemas.openxmlformats.org/presentationml/2006/main">
+  <p:cSld>
+    <p:bg>
+      <p:bgPr>
+        <a:solidFill>
+          <a:srgbClr val="FAF7F4"/>
+        </a:solidFill>
+        <a:effectLst/>
+      </p:bgPr>
+    </p:bg>
+    <p:spTree>
+      <p:nvGrpSpPr>
+        <p:cNvPr id="1" name=""/>
+        <p:cNvGrpSpPr/>
+        <p:nvPr/>
+      </p:nvGrpSpPr>
+      <p:grpSpPr>
+        <a:xfrm>
+          <a:off x="0" y="0"/>
+          <a:ext cx="0" cy="0"/>
+          <a:chOff x="0" y="0"/>
+          <a:chExt cx="0" cy="0"/>
+        </a:xfrm>
+      </p:grpSpPr>
+      <p:sp>
+        <p:nvSpPr>
+          <p:cNvPr id="2" name="Rectangle 1"/>
+          <p:cNvSpPr/>
+          <p:nvPr/>
+        </p:nvSpPr>
+        <p:spPr>
+          <a:xfrm>
+            <a:off x="0" y="0"/>
+            <a:ext cx="9144000" cy="73152"/>
+          </a:xfrm>
+          <a:prstGeom prst="rect">
+            <a:avLst/>
+          </a:prstGeom>
+          <a:solidFill>
+            <a:srgbClr val="C8382A"/>
+          </a:solidFill>
+          <a:ln>
+            <a:noFill/>
+          </a:ln>
+        </p:spPr>
+        <p:style>
+          <a:lnRef idx="1">
+            <a:schemeClr val="accent1"/>
+          </a:lnRef>
+          <a:fillRef idx="3">
+            <a:schemeClr val="accent1"/>
+          </a:fillRef>
+          <a:effectRef idx="2">
+            <a:schemeClr val="accent1"/>
+          </a:effectRef>
+          <a:fontRef idx="minor">
+            <a:schemeClr val="lt1"/>
+          </a:fontRef>
+        </p:style>
+        <p:txBody>
+          <a:bodyPr rtlCol="0" anchor="ctr"/>
+          <a:lstStyle/>
+          <a:p>
+            <a:pPr algn="ctr"/>
+            <a:endParaRPr/>
+          </a:p>
+        </p:txBody>
+      </p:sp>
+      <p:sp>
+        <p:nvSpPr>
+          <p:cNvPr id="3" name="TextBox 2"/>
+          <p:cNvSpPr txBox="1"/>
+          <p:nvPr/>
+        </p:nvSpPr>
+        <p:spPr>
+          <a:xfrm>
+            <a:off x="365760" y="164592"/>
+            <a:ext cx="8229600" cy="548640"/>
+          </a:xfrm>
+          <a:prstGeom prst="rect">
+            <a:avLst/>
+          </a:prstGeom>
+          <a:noFill/>
+        </p:spPr>
+        <p:txBody>
+          <a:bodyPr wrap="square">
+            <a:spAutoFit/>
+          </a:bodyPr>
+          <a:lstStyle/>
+          <a:p>
+            <a:pPr algn="l"/>
+            <a:r>
+              <a:rPr sz="2200" b="1">
+                <a:solidFill>
+                  <a:srgbClr val="1A1410"/>
+                </a:solidFill>
+              </a:rPr>
+              <a:t>Comparativo MAE, RMSE e R² — 3 Modelos</a:t>
+            </a:r>
+          </a:p>
+        </p:txBody>
+      </p:sp>
+      <p:sp>
+        <p:nvSpPr>
+          <p:cNvPr id="4" name="TextBox 3"/>
+          <p:cNvSpPr txBox="1"/>
+          <p:nvPr/>
+        </p:nvSpPr>
+        <p:spPr>
+          <a:xfrm>
+            <a:off x="365760" y="685800"/>
+            <a:ext cx="8229600" cy="365760"/>
+          </a:xfrm>
+          <a:prstGeom prst="rect">
+            <a:avLst/>
+          </a:prstGeom>
+          <a:noFill/>
+        </p:spPr>
+        <p:txBody>
+          <a:bodyPr wrap="square">
+            <a:spAutoFit/>
+          </a:bodyPr>
+          <a:lstStyle/>
+          <a:p>
+            <a:pPr algn="l"/>
+            <a:r>
+              <a:rPr sz="1200" b="0">
+                <a:solidFill>
+                  <a:srgbClr val="6B5E58"/>
+                </a:solidFill>
+              </a:rPr>
+              <a:t>XGBoost obteve menor MAE (14,3 casos/semana)</a:t>
+            </a:r>
+          </a:p>
+        </p:txBody>
+      </p:sp>
+      <p:pic>
+        <p:nvPicPr>
+          <p:cNvPr id="5" name="Picture 4" descr="comparativo_modelos.png"/>
+          <p:cNvPicPr>
+            <a:picLocks noChangeAspect="1"/>
+          </p:cNvPicPr>
+          <p:nvPr/>
+        </p:nvPicPr>
+        <p:blipFill>
+          <a:blip r:embed="rId2"/>
+          <a:stretch>
+            <a:fillRect/>
+          </a:stretch>
+        </p:blipFill>
+        <p:spPr>
+          <a:xfrm>
+            <a:off x="457200" y="1463040"/>
+            <a:ext cx="8229600" cy="2460519"/>
+          </a:xfrm>
+          <a:prstGeom prst="rect">
+            <a:avLst/>
+          </a:prstGeom>
+        </p:spPr>
+      </p:pic>
+    </p:spTree>
+  </p:cSld>
+  <p:clrMapOvr>
+    <a:masterClrMapping/>
+  </p:clrMapOvr>
+</p:sld>
+</file>
+
+<file path=ppt/slides/slide9.xml><?xml version="1.0" encoding="utf-8"?>
+<p:sld xmlns:a="http://schemas.openxmlformats.org/drawingml/2006/main" xmlns:r="http://schemas.openxmlformats.org/officeDocument/2006/relationships" xmlns:p="http://schemas.openxmlformats.org/presentationml/2006/main">
+  <p:cSld>
+    <p:bg>
+      <p:bgPr>
+        <a:solidFill>
+          <a:srgbClr val="FAF7F4"/>
+        </a:solidFill>
+        <a:effectLst/>
+      </p:bgPr>
+    </p:bg>
+    <p:spTree>
+      <p:nvGrpSpPr>
+        <p:cNvPr id="1" name=""/>
+        <p:cNvGrpSpPr/>
+        <p:nvPr/>
+      </p:nvGrpSpPr>
+      <p:grpSpPr>
+        <a:xfrm>
+          <a:off x="0" y="0"/>
+          <a:ext cx="0" cy="0"/>
+          <a:chOff x="0" y="0"/>
+          <a:chExt cx="0" cy="0"/>
+        </a:xfrm>
+      </p:grpSpPr>
+      <p:sp>
+        <p:nvSpPr>
+          <p:cNvPr id="2" name="Rectangle 1"/>
+          <p:cNvSpPr/>
+          <p:nvPr/>
+        </p:nvSpPr>
+        <p:spPr>
+          <a:xfrm>
+            <a:off x="0" y="0"/>
+            <a:ext cx="9144000" cy="73152"/>
+          </a:xfrm>
+          <a:prstGeom prst="rect">
+            <a:avLst/>
+          </a:prstGeom>
+          <a:solidFill>
+            <a:srgbClr val="C8382A"/>
+          </a:solidFill>
+          <a:ln>
+            <a:noFill/>
+          </a:ln>
+        </p:spPr>
+        <p:style>
+          <a:lnRef idx="1">
+            <a:schemeClr val="accent1"/>
+          </a:lnRef>
+          <a:fillRef idx="3">
+            <a:schemeClr val="accent1"/>
+          </a:fillRef>
+          <a:effectRef idx="2">
+            <a:schemeClr val="accent1"/>
+          </a:effectRef>
+          <a:fontRef idx="minor">
+            <a:schemeClr val="lt1"/>
+          </a:fontRef>
+        </p:style>
+        <p:txBody>
+          <a:bodyPr rtlCol="0" anchor="ctr"/>
+          <a:lstStyle/>
+          <a:p>
+            <a:pPr algn="ctr"/>
+            <a:endParaRPr/>
+          </a:p>
+        </p:txBody>
+      </p:sp>
+      <p:sp>
+        <p:nvSpPr>
+          <p:cNvPr id="3" name="TextBox 2"/>
+          <p:cNvSpPr txBox="1"/>
+          <p:nvPr/>
+        </p:nvSpPr>
+        <p:spPr>
+          <a:xfrm>
+            <a:off x="365760" y="164592"/>
+            <a:ext cx="8229600" cy="548640"/>
+          </a:xfrm>
+          <a:prstGeom prst="rect">
+            <a:avLst/>
+          </a:prstGeom>
+          <a:noFill/>
+        </p:spPr>
+        <p:txBody>
+          <a:bodyPr wrap="square">
+            <a:spAutoFit/>
+          </a:bodyPr>
+          <a:lstStyle/>
+          <a:p>
+            <a:pPr algn="l"/>
+            <a:r>
+              <a:rPr sz="2200" b="1">
+                <a:solidFill>
+                  <a:srgbClr val="1A1410"/>
+                </a:solidFill>
+              </a:rPr>
+              <a:t>Importância das Features — XGBoost</a:t>
+            </a:r>
+          </a:p>
+        </p:txBody>
+      </p:sp>
+      <p:sp>
+        <p:nvSpPr>
+          <p:cNvPr id="4" name="TextBox 3"/>
+          <p:cNvSpPr txBox="1"/>
+          <p:nvPr/>
+        </p:nvSpPr>
+        <p:spPr>
+          <a:xfrm>
+            <a:off x="365760" y="685800"/>
+            <a:ext cx="8229600" cy="365760"/>
+          </a:xfrm>
+          <a:prstGeom prst="rect">
+            <a:avLst/>
+          </a:prstGeom>
+          <a:noFill/>
+        </p:spPr>
+        <p:txBody>
+          <a:bodyPr wrap="square">
+            <a:spAutoFit/>
+          </a:bodyPr>
+          <a:lstStyle/>
+          <a:p>
+            <a:pPr algn="l"/>
+            <a:r>
+              <a:rPr sz="1200" b="0">
+                <a:solidFill>
+                  <a:srgbClr val="6B5E58"/>
+                </a:solidFill>
+              </a:rPr>
+              <a:t>Lag features dominam: casos das semanas anteriores explicam &gt;70% do modelo</a:t>
+            </a:r>
+          </a:p>
+        </p:txBody>
+      </p:sp>
+      <p:pic>
+        <p:nvPicPr>
+          <p:cNvPr id="5" name="Picture 4" descr="importancia_features.png"/>
+          <p:cNvPicPr>
+            <a:picLocks noChangeAspect="1"/>
+          </p:cNvPicPr>
+          <p:nvPr/>
+        </p:nvPicPr>
+        <p:blipFill>
+          <a:blip r:embed="rId2"/>
+          <a:stretch>
+            <a:fillRect/>
+          </a:stretch>
+        </p:blipFill>
+        <p:spPr>
+          <a:xfrm>
+            <a:off x="457200" y="1463040"/>
+            <a:ext cx="8229600" cy="5090546"/>
           </a:xfrm>
           <a:prstGeom prst="rect">
             <a:avLst/>

</xml_diff>